<commit_message>
style: perfect text alignments, typography, and card coordinates across all 6 slides
</commit_message>
<xml_diff>
--- a/PACKWISE_AI_SIH2026_Submission.pptx
+++ b/PACKWISE_AI_SIH2026_Submission.pptx
@@ -3101,8 +3101,8 @@
         </p:nvSpPr>
         <p:spPr>
           <a:xfrm>
-            <a:off x="914400" y="457200"/>
-            <a:ext cx="10360152" cy="731520"/>
+            <a:off x="914400" y="438912"/>
+            <a:ext cx="10362895" cy="685800"/>
           </a:xfrm>
           <a:prstGeom prst="rect">
             <a:avLst/>
@@ -3120,6 +3120,7 @@
                 <a:solidFill>
                   <a:srgbClr val="1A365D"/>
                 </a:solidFill>
+                <a:latin typeface="Calibri"/>
               </a:defRPr>
             </a:pPr>
             <a:r>
@@ -3136,8 +3137,8 @@
         </p:nvSpPr>
         <p:spPr>
           <a:xfrm>
-            <a:off x="914400" y="1234440"/>
-            <a:ext cx="10360152" cy="548640"/>
+            <a:off x="914400" y="1188720"/>
+            <a:ext cx="10362895" cy="457200"/>
           </a:xfrm>
           <a:prstGeom prst="rect">
             <a:avLst/>
@@ -3151,10 +3152,11 @@
           <a:lstStyle/>
           <a:p>
             <a:pPr algn="ctr">
-              <a:defRPr sz="2400" b="1">
+              <a:defRPr sz="2200" b="1">
                 <a:solidFill>
                   <a:srgbClr val="1A365D"/>
                 </a:solidFill>
+                <a:latin typeface="Calibri"/>
               </a:defRPr>
             </a:pPr>
             <a:r>
@@ -3171,8 +3173,8 @@
         </p:nvSpPr>
         <p:spPr>
           <a:xfrm>
-            <a:off x="640080" y="1920240"/>
-            <a:ext cx="7315200" cy="4297680"/>
+            <a:off x="731520" y="1783080"/>
+            <a:ext cx="7223760" cy="4480560"/>
           </a:xfrm>
           <a:prstGeom prst="roundRect">
             <a:avLst/>
@@ -3182,7 +3184,7 @@
           </a:solidFill>
           <a:ln w="19050">
             <a:solidFill>
-              <a:srgbClr val="E2E8F0"/>
+              <a:srgbClr val="CBD5E1"/>
             </a:solidFill>
           </a:ln>
         </p:spPr>
@@ -3201,10 +3203,52 @@
           </a:fontRef>
         </p:style>
         <p:txBody>
-          <a:bodyPr rtlCol="0" anchor="ctr" wrap="square" lIns="320040" rIns="320040" tIns="320040"/>
-          <a:lstStyle/>
-          <a:p>
-            <a:pPr algn="ctr">
+          <a:bodyPr rtlCol="0" anchor="ctr"/>
+          <a:lstStyle/>
+          <a:p>
+            <a:pPr algn="ctr"/>
+          </a:p>
+        </p:txBody>
+      </p:sp>
+      <p:sp>
+        <p:nvSpPr>
+          <p:cNvPr id="5" name="TextBox 4"/>
+          <p:cNvSpPr txBox="1"/>
+          <p:nvPr/>
+        </p:nvSpPr>
+        <p:spPr>
+          <a:xfrm>
+            <a:off x="960120" y="1984248"/>
+            <a:ext cx="6766560" cy="4078224"/>
+          </a:xfrm>
+          <a:prstGeom prst="rect">
+            <a:avLst/>
+          </a:prstGeom>
+          <a:noFill/>
+        </p:spPr>
+        <p:txBody>
+          <a:bodyPr wrap="square" lIns="0" rIns="0" tIns="0" bIns="0">
+            <a:spAutoFit/>
+          </a:bodyPr>
+          <a:lstStyle/>
+          <a:p>
+            <a:pPr>
+              <a:spcAft>
+                <a:spcPts val="1400"/>
+              </a:spcAft>
+              <a:defRPr sz="1400" b="1">
+                <a:solidFill>
+                  <a:srgbClr val="1A365D"/>
+                </a:solidFill>
+                <a:latin typeface="Calibri"/>
+              </a:defRPr>
+            </a:pPr>
+            <a:r>
+              <a:t>📋 Idea Submission Profile</a:t>
+            </a:r>
+          </a:p>
+          <a:p>
+            <a:pPr algn="l">
               <a:spcAft>
                 <a:spcPts val="1200"/>
               </a:spcAft>
@@ -3214,6 +3258,7 @@
                 <a:solidFill>
                   <a:srgbClr val="1A365D"/>
                 </a:solidFill>
+                <a:latin typeface="Calibri"/>
               </a:rPr>
               <a:t>• Problem Statement ID – </a:t>
             </a:r>
@@ -3222,12 +3267,13 @@
                 <a:solidFill>
                   <a:srgbClr val="0D9488"/>
                 </a:solidFill>
+                <a:latin typeface="Calibri"/>
               </a:rPr>
               <a:t>SIH26236</a:t>
             </a:r>
           </a:p>
           <a:p>
-            <a:pPr>
+            <a:pPr algn="l">
               <a:spcAft>
                 <a:spcPts val="1200"/>
               </a:spcAft>
@@ -3237,6 +3283,7 @@
                 <a:solidFill>
                   <a:srgbClr val="1A365D"/>
                 </a:solidFill>
+                <a:latin typeface="Calibri"/>
               </a:rPr>
               <a:t>• Problem Statement Title – </a:t>
             </a:r>
@@ -3245,12 +3292,13 @@
                 <a:solidFill>
                   <a:srgbClr val="1E293B"/>
                 </a:solidFill>
+                <a:latin typeface="Calibri"/>
               </a:rPr>
               <a:t>AI-Based Intelligent Food Packaging Material Recommendation System for Food Commodities</a:t>
             </a:r>
           </a:p>
           <a:p>
-            <a:pPr>
+            <a:pPr algn="l">
               <a:spcAft>
                 <a:spcPts val="1200"/>
               </a:spcAft>
@@ -3260,6 +3308,7 @@
                 <a:solidFill>
                   <a:srgbClr val="1A365D"/>
                 </a:solidFill>
+                <a:latin typeface="Calibri"/>
               </a:rPr>
               <a:t>• Theme – </a:t>
             </a:r>
@@ -3268,12 +3317,13 @@
                 <a:solidFill>
                   <a:srgbClr val="1A365D"/>
                 </a:solidFill>
+                <a:latin typeface="Calibri"/>
               </a:rPr>
               <a:t>Agriculture, FoodTech &amp; Rural Development</a:t>
             </a:r>
           </a:p>
           <a:p>
-            <a:pPr>
+            <a:pPr algn="l">
               <a:spcAft>
                 <a:spcPts val="1200"/>
               </a:spcAft>
@@ -3283,6 +3333,7 @@
                 <a:solidFill>
                   <a:srgbClr val="1A365D"/>
                 </a:solidFill>
+                <a:latin typeface="Calibri"/>
               </a:rPr>
               <a:t>• PS Category – </a:t>
             </a:r>
@@ -3291,12 +3342,13 @@
                 <a:solidFill>
                   <a:srgbClr val="0284C7"/>
                 </a:solidFill>
+                <a:latin typeface="Calibri"/>
               </a:rPr>
               <a:t>Software Edition</a:t>
             </a:r>
           </a:p>
           <a:p>
-            <a:pPr>
+            <a:pPr algn="l">
               <a:spcAft>
                 <a:spcPts val="1200"/>
               </a:spcAft>
@@ -3306,6 +3358,7 @@
                 <a:solidFill>
                   <a:srgbClr val="1A365D"/>
                 </a:solidFill>
+                <a:latin typeface="Calibri"/>
               </a:rPr>
               <a:t>• Ministry / Organization – </a:t>
             </a:r>
@@ -3314,12 +3367,13 @@
                 <a:solidFill>
                   <a:srgbClr val="1E293B"/>
                 </a:solidFill>
+                <a:latin typeface="Calibri"/>
               </a:rPr>
               <a:t>Ministry of Food Processing Industries (MoFPI)</a:t>
             </a:r>
           </a:p>
           <a:p>
-            <a:pPr>
+            <a:pPr algn="l">
               <a:spcAft>
                 <a:spcPts val="1200"/>
               </a:spcAft>
@@ -3329,6 +3383,7 @@
                 <a:solidFill>
                   <a:srgbClr val="1A365D"/>
                 </a:solidFill>
+                <a:latin typeface="Calibri"/>
               </a:rPr>
               <a:t>• Team Name – </a:t>
             </a:r>
@@ -3337,54 +3392,10 @@
                 <a:solidFill>
                   <a:srgbClr val="B91C1C"/>
                 </a:solidFill>
+                <a:latin typeface="Calibri"/>
               </a:rPr>
               <a:t>Syndicate IX</a:t>
             </a:r>
-          </a:p>
-        </p:txBody>
-      </p:sp>
-      <p:sp>
-        <p:nvSpPr>
-          <p:cNvPr id="5" name="Rounded Rectangle 4"/>
-          <p:cNvSpPr/>
-          <p:nvPr/>
-        </p:nvSpPr>
-        <p:spPr>
-          <a:xfrm>
-            <a:off x="640080" y="1920240"/>
-            <a:ext cx="7315200" cy="109728"/>
-          </a:xfrm>
-          <a:prstGeom prst="roundRect">
-            <a:avLst/>
-          </a:prstGeom>
-          <a:solidFill>
-            <a:srgbClr val="1A365D"/>
-          </a:solidFill>
-          <a:ln>
-            <a:solidFill>
-              <a:srgbClr val="1A365D"/>
-            </a:solidFill>
-          </a:ln>
-        </p:spPr>
-        <p:style>
-          <a:lnRef idx="1">
-            <a:schemeClr val="accent1"/>
-          </a:lnRef>
-          <a:fillRef idx="3">
-            <a:schemeClr val="accent1"/>
-          </a:fillRef>
-          <a:effectRef idx="2">
-            <a:schemeClr val="accent1"/>
-          </a:effectRef>
-          <a:fontRef idx="minor">
-            <a:schemeClr val="lt1"/>
-          </a:fontRef>
-        </p:style>
-        <p:txBody>
-          <a:bodyPr rtlCol="0" anchor="ctr"/>
-          <a:lstStyle/>
-          <a:p>
-            <a:pPr algn="ctr"/>
           </a:p>
         </p:txBody>
       </p:sp>
@@ -3396,8 +3407,8 @@
         </p:nvSpPr>
         <p:spPr>
           <a:xfrm>
-            <a:off x="8229600" y="1920240"/>
-            <a:ext cx="3291840" cy="4297680"/>
+            <a:off x="8183879" y="1783080"/>
+            <a:ext cx="3276295" cy="4480560"/>
           </a:xfrm>
           <a:prstGeom prst="roundRect">
             <a:avLst/>
@@ -3426,10 +3437,39 @@
           </a:fontRef>
         </p:style>
         <p:txBody>
-          <a:bodyPr rtlCol="0" anchor="ctr" wrap="square" lIns="228600" rIns="228600" tIns="365760"/>
+          <a:bodyPr rtlCol="0" anchor="ctr"/>
+          <a:lstStyle/>
+          <a:p>
+            <a:pPr algn="ctr"/>
+          </a:p>
+        </p:txBody>
+      </p:sp>
+      <p:sp>
+        <p:nvSpPr>
+          <p:cNvPr id="7" name="TextBox 6"/>
+          <p:cNvSpPr txBox="1"/>
+          <p:nvPr/>
+        </p:nvSpPr>
+        <p:spPr>
+          <a:xfrm>
+            <a:off x="8412480" y="1984248"/>
+            <a:ext cx="2819095" cy="4078224"/>
+          </a:xfrm>
+          <a:prstGeom prst="rect">
+            <a:avLst/>
+          </a:prstGeom>
+          <a:noFill/>
+        </p:spPr>
+        <p:txBody>
+          <a:bodyPr wrap="square" lIns="0" rIns="0" tIns="0" bIns="0">
+            <a:spAutoFit/>
+          </a:bodyPr>
           <a:lstStyle/>
           <a:p>
             <a:pPr algn="ctr">
+              <a:spcAft>
+                <a:spcPts val="400"/>
+              </a:spcAft>
               <a:defRPr sz="4400"/>
             </a:pPr>
             <a:r>
@@ -3438,13 +3478,11 @@
           </a:p>
           <a:p>
             <a:pPr algn="ctr">
-              <a:spcBef>
-                <a:spcPts val="800"/>
-              </a:spcBef>
               <a:defRPr sz="2200" b="1">
                 <a:solidFill>
                   <a:srgbClr val="0D9488"/>
                 </a:solidFill>
+                <a:latin typeface="Calibri"/>
               </a:defRPr>
             </a:pPr>
             <a:r>
@@ -3453,13 +3491,14 @@
           </a:p>
           <a:p>
             <a:pPr algn="ctr">
-              <a:spcBef>
-                <a:spcPts val="400"/>
-              </a:spcBef>
+              <a:spcAft>
+                <a:spcPts val="1800"/>
+              </a:spcAft>
               <a:defRPr sz="1100" b="1">
                 <a:solidFill>
                   <a:srgbClr val="1A365D"/>
                 </a:solidFill>
+                <a:latin typeface="Calibri"/>
               </a:defRPr>
             </a:pPr>
             <a:r>
@@ -3468,13 +3507,14 @@
           </a:p>
           <a:p>
             <a:pPr algn="ctr">
-              <a:spcBef>
+              <a:spcAft>
                 <a:spcPts val="1200"/>
-              </a:spcBef>
-              <a:defRPr sz="1100" b="1">
+              </a:spcAft>
+              <a:defRPr sz="1200" b="1">
                 <a:solidFill>
                   <a:srgbClr val="0D9488"/>
                 </a:solidFill>
+                <a:latin typeface="Calibri"/>
               </a:defRPr>
             </a:pPr>
             <a:r>
@@ -3483,13 +3523,14 @@
           </a:p>
           <a:p>
             <a:pPr algn="ctr">
-              <a:spcBef>
+              <a:spcAft>
                 <a:spcPts val="1200"/>
-              </a:spcBef>
-              <a:defRPr sz="1100" b="1">
+              </a:spcAft>
+              <a:defRPr sz="1200" b="1">
                 <a:solidFill>
                   <a:srgbClr val="0284C7"/>
                 </a:solidFill>
+                <a:latin typeface="Calibri"/>
               </a:defRPr>
             </a:pPr>
             <a:r>
@@ -3498,13 +3539,14 @@
           </a:p>
           <a:p>
             <a:pPr algn="ctr">
-              <a:spcBef>
+              <a:spcAft>
                 <a:spcPts val="1200"/>
-              </a:spcBef>
-              <a:defRPr sz="1100" b="1">
+              </a:spcAft>
+              <a:defRPr sz="1200" b="1">
                 <a:solidFill>
                   <a:srgbClr val="D97706"/>
                 </a:solidFill>
+                <a:latin typeface="Calibri"/>
               </a:defRPr>
             </a:pPr>
             <a:r>
@@ -3515,7 +3557,7 @@
       </p:sp>
       <p:sp>
         <p:nvSpPr>
-          <p:cNvPr id="7" name="Rectangle 6"/>
+          <p:cNvPr id="8" name="Rectangle 7"/>
           <p:cNvSpPr/>
           <p:nvPr/>
         </p:nvSpPr>
@@ -3584,8 +3626,8 @@
         </p:nvSpPr>
         <p:spPr>
           <a:xfrm>
-            <a:off x="640080" y="256032"/>
-            <a:ext cx="2926080" cy="365760"/>
+            <a:off x="731520" y="256032"/>
+            <a:ext cx="3200400" cy="365760"/>
           </a:xfrm>
           <a:prstGeom prst="rect">
             <a:avLst/>
@@ -3593,7 +3635,7 @@
           <a:noFill/>
         </p:spPr>
         <p:txBody>
-          <a:bodyPr wrap="square">
+          <a:bodyPr wrap="square" lIns="0" rIns="0" tIns="0" bIns="0">
             <a:spAutoFit/>
           </a:bodyPr>
           <a:lstStyle/>
@@ -3603,6 +3645,7 @@
                 <a:solidFill>
                   <a:srgbClr val="B91C1C"/>
                 </a:solidFill>
+                <a:latin typeface="Calibri"/>
               </a:defRPr>
             </a:pPr>
             <a:r>
@@ -3619,8 +3662,8 @@
         </p:nvSpPr>
         <p:spPr>
           <a:xfrm>
-            <a:off x="8778240" y="256032"/>
-            <a:ext cx="2743200" cy="365760"/>
+            <a:off x="8229600" y="256032"/>
+            <a:ext cx="3230575" cy="365760"/>
           </a:xfrm>
           <a:prstGeom prst="rect">
             <a:avLst/>
@@ -3628,7 +3671,7 @@
           <a:noFill/>
         </p:spPr>
         <p:txBody>
-          <a:bodyPr wrap="square">
+          <a:bodyPr wrap="square" lIns="0" rIns="0" tIns="0" bIns="0">
             <a:spAutoFit/>
           </a:bodyPr>
           <a:lstStyle/>
@@ -3638,6 +3681,7 @@
                 <a:solidFill>
                   <a:srgbClr val="1A365D"/>
                 </a:solidFill>
+                <a:latin typeface="Calibri"/>
               </a:defRPr>
             </a:pPr>
             <a:r>
@@ -3718,6 +3762,7 @@
                 <a:solidFill>
                   <a:srgbClr val="FFFFFF"/>
                 </a:solidFill>
+                <a:latin typeface="Calibri"/>
               </a:defRPr>
             </a:pPr>
             <a:r>
@@ -3734,8 +3779,8 @@
         </p:nvSpPr>
         <p:spPr>
           <a:xfrm>
-            <a:off x="1371600" y="502920"/>
-            <a:ext cx="9445752" cy="548640"/>
+            <a:off x="1371600" y="457200"/>
+            <a:ext cx="9448495" cy="548640"/>
           </a:xfrm>
           <a:prstGeom prst="rect">
             <a:avLst/>
@@ -3753,6 +3798,7 @@
                 <a:solidFill>
                   <a:srgbClr val="0D9488"/>
                 </a:solidFill>
+                <a:latin typeface="Calibri"/>
               </a:defRPr>
             </a:pPr>
             <a:r>
@@ -3769,8 +3815,8 @@
         </p:nvSpPr>
         <p:spPr>
           <a:xfrm>
-            <a:off x="1371600" y="1051560"/>
-            <a:ext cx="9445752" cy="365760"/>
+            <a:off x="1371600" y="1024128"/>
+            <a:ext cx="9448495" cy="365760"/>
           </a:xfrm>
           <a:prstGeom prst="rect">
             <a:avLst/>
@@ -3788,6 +3834,7 @@
                 <a:solidFill>
                   <a:srgbClr val="1A365D"/>
                 </a:solidFill>
+                <a:latin typeface="Calibri"/>
               </a:defRPr>
             </a:pPr>
             <a:r>
@@ -3804,8 +3851,8 @@
         </p:nvSpPr>
         <p:spPr>
           <a:xfrm>
-            <a:off x="640080" y="1554480"/>
-            <a:ext cx="5120640" cy="4709160"/>
+            <a:off x="731520" y="1463040"/>
+            <a:ext cx="5166360" cy="4800600"/>
           </a:xfrm>
           <a:prstGeom prst="roundRect">
             <a:avLst/>
@@ -3815,7 +3862,7 @@
           </a:solidFill>
           <a:ln w="19050">
             <a:solidFill>
-              <a:srgbClr val="E2E8F0"/>
+              <a:srgbClr val="CBD5E1"/>
             </a:solidFill>
           </a:ln>
         </p:spPr>
@@ -3834,34 +3881,62 @@
           </a:fontRef>
         </p:style>
         <p:txBody>
-          <a:bodyPr rtlCol="0" anchor="ctr" wrap="square" lIns="320040" rIns="320040" tIns="274320"/>
-          <a:lstStyle/>
-          <a:p>
-            <a:pPr algn="ctr">
+          <a:bodyPr rtlCol="0" anchor="ctr"/>
+          <a:lstStyle/>
+          <a:p>
+            <a:pPr algn="ctr"/>
+          </a:p>
+        </p:txBody>
+      </p:sp>
+      <p:sp>
+        <p:nvSpPr>
+          <p:cNvPr id="9" name="TextBox 8"/>
+          <p:cNvSpPr txBox="1"/>
+          <p:nvPr/>
+        </p:nvSpPr>
+        <p:spPr>
+          <a:xfrm>
+            <a:off x="960120" y="1664208"/>
+            <a:ext cx="4709160" cy="4398264"/>
+          </a:xfrm>
+          <a:prstGeom prst="rect">
+            <a:avLst/>
+          </a:prstGeom>
+          <a:noFill/>
+        </p:spPr>
+        <p:txBody>
+          <a:bodyPr wrap="square" lIns="0" rIns="0" tIns="0" bIns="0">
+            <a:spAutoFit/>
+          </a:bodyPr>
+          <a:lstStyle/>
+          <a:p>
+            <a:pPr>
+              <a:spcAft>
+                <a:spcPts val="1400"/>
+              </a:spcAft>
+              <a:defRPr sz="1550" b="1">
+                <a:solidFill>
+                  <a:srgbClr val="B91C1C"/>
+                </a:solidFill>
+                <a:latin typeface="Calibri"/>
+              </a:defRPr>
+            </a:pPr>
+            <a:r>
+              <a:t>⚠️ The Problem &amp; National Challenge</a:t>
+            </a:r>
+          </a:p>
+          <a:p>
+            <a:pPr>
               <a:spcAft>
                 <a:spcPts val="1200"/>
               </a:spcAft>
-              <a:defRPr sz="1600" b="1">
-                <a:solidFill>
-                  <a:srgbClr val="B91C1C"/>
-                </a:solidFill>
-              </a:defRPr>
-            </a:pPr>
-            <a:r>
-              <a:t>⚠️ The Problem &amp; National Challenge</a:t>
-            </a:r>
-          </a:p>
-          <a:p>
-            <a:pPr>
-              <a:spcAft>
-                <a:spcPts val="1000"/>
-              </a:spcAft>
             </a:pPr>
             <a:r>
               <a:rPr b="1" sz="1150">
                 <a:solidFill>
                   <a:srgbClr val="1A365D"/>
                 </a:solidFill>
+                <a:latin typeface="Calibri"/>
               </a:rPr>
               <a:t>• Severe Post-Harvest Loss:</a:t>
             </a:r>
@@ -3870,6 +3945,7 @@
                 <a:solidFill>
                   <a:srgbClr val="1E293B"/>
                 </a:solidFill>
+                <a:latin typeface="Calibri"/>
               </a:rPr>
               <a:t> India loses ₹1.52+ Lakh Cr annually (~19.33 MMT fruit/vegetable wastage) due to inadequate packaging.</a:t>
             </a:r>
@@ -3877,7 +3953,7 @@
           <a:p>
             <a:pPr>
               <a:spcAft>
-                <a:spcPts val="1000"/>
+                <a:spcPts val="1200"/>
               </a:spcAft>
             </a:pPr>
             <a:r>
@@ -3885,6 +3961,7 @@
                 <a:solidFill>
                   <a:srgbClr val="1A365D"/>
                 </a:solidFill>
+                <a:latin typeface="Calibri"/>
               </a:rPr>
               <a:t>• Plastic Pollution &amp; EPR Penalty:</a:t>
             </a:r>
@@ -3893,6 +3970,7 @@
                 <a:solidFill>
                   <a:srgbClr val="1E293B"/>
                 </a:solidFill>
+                <a:latin typeface="Calibri"/>
               </a:rPr>
               <a:t> Single-use multi-layer plastic pouches cannot be recycled and face severe CPCB 2026 EPR penalties.</a:t>
             </a:r>
@@ -3900,7 +3978,7 @@
           <a:p>
             <a:pPr>
               <a:spcAft>
-                <a:spcPts val="1000"/>
+                <a:spcPts val="1200"/>
               </a:spcAft>
             </a:pPr>
             <a:r>
@@ -3908,6 +3986,7 @@
                 <a:solidFill>
                   <a:srgbClr val="1A365D"/>
                 </a:solidFill>
+                <a:latin typeface="Calibri"/>
               </a:rPr>
               <a:t>• Barrier Mismatch:</a:t>
             </a:r>
@@ -3916,6 +3995,7 @@
                 <a:solidFill>
                   <a:srgbClr val="1E293B"/>
                 </a:solidFill>
+                <a:latin typeface="Calibri"/>
               </a:rPr>
               <a:t> Perishables packed in generic LDPE suffer condensation rotting, mold bloom, or moisture desiccation.</a:t>
             </a:r>
@@ -3923,7 +4003,7 @@
           <a:p>
             <a:pPr>
               <a:spcAft>
-                <a:spcPts val="1000"/>
+                <a:spcPts val="1200"/>
               </a:spcAft>
             </a:pPr>
             <a:r>
@@ -3931,6 +4011,7 @@
                 <a:solidFill>
                   <a:srgbClr val="1A365D"/>
                 </a:solidFill>
+                <a:latin typeface="Calibri"/>
               </a:rPr>
               <a:t>• MSME &amp; FPO Bottleneck:</a:t>
             </a:r>
@@ -3939,54 +4020,10 @@
                 <a:solidFill>
                   <a:srgbClr val="1E293B"/>
                 </a:solidFill>
+                <a:latin typeface="Calibri"/>
               </a:rPr>
               <a:t> Rural processors lack R&amp;D testing labs and miss out on available MoFPI PMFME capital subsidies.</a:t>
             </a:r>
-          </a:p>
-        </p:txBody>
-      </p:sp>
-      <p:sp>
-        <p:nvSpPr>
-          <p:cNvPr id="9" name="Rounded Rectangle 8"/>
-          <p:cNvSpPr/>
-          <p:nvPr/>
-        </p:nvSpPr>
-        <p:spPr>
-          <a:xfrm>
-            <a:off x="640080" y="1554480"/>
-            <a:ext cx="5120640" cy="109728"/>
-          </a:xfrm>
-          <a:prstGeom prst="roundRect">
-            <a:avLst/>
-          </a:prstGeom>
-          <a:solidFill>
-            <a:srgbClr val="B91C1C"/>
-          </a:solidFill>
-          <a:ln>
-            <a:solidFill>
-              <a:srgbClr val="B91C1C"/>
-            </a:solidFill>
-          </a:ln>
-        </p:spPr>
-        <p:style>
-          <a:lnRef idx="1">
-            <a:schemeClr val="accent1"/>
-          </a:lnRef>
-          <a:fillRef idx="3">
-            <a:schemeClr val="accent1"/>
-          </a:fillRef>
-          <a:effectRef idx="2">
-            <a:schemeClr val="accent1"/>
-          </a:effectRef>
-          <a:fontRef idx="minor">
-            <a:schemeClr val="lt1"/>
-          </a:fontRef>
-        </p:style>
-        <p:txBody>
-          <a:bodyPr rtlCol="0" anchor="ctr"/>
-          <a:lstStyle/>
-          <a:p>
-            <a:pPr algn="ctr"/>
           </a:p>
         </p:txBody>
       </p:sp>
@@ -3998,8 +4035,8 @@
         </p:nvSpPr>
         <p:spPr>
           <a:xfrm>
-            <a:off x="6035040" y="1554480"/>
-            <a:ext cx="5486400" cy="4709160"/>
+            <a:off x="6172200" y="1463040"/>
+            <a:ext cx="5287975" cy="4800600"/>
           </a:xfrm>
           <a:prstGeom prst="roundRect">
             <a:avLst/>
@@ -4028,17 +4065,44 @@
           </a:fontRef>
         </p:style>
         <p:txBody>
-          <a:bodyPr rtlCol="0" anchor="ctr" wrap="square" lIns="320040" rIns="320040" tIns="274320"/>
-          <a:lstStyle/>
-          <a:p>
-            <a:pPr algn="ctr">
-              <a:spcAft>
-                <a:spcPts val="1000"/>
-              </a:spcAft>
-              <a:defRPr sz="1600" b="1">
+          <a:bodyPr rtlCol="0" anchor="ctr"/>
+          <a:lstStyle/>
+          <a:p>
+            <a:pPr algn="ctr"/>
+          </a:p>
+        </p:txBody>
+      </p:sp>
+      <p:sp>
+        <p:nvSpPr>
+          <p:cNvPr id="11" name="TextBox 10"/>
+          <p:cNvSpPr txBox="1"/>
+          <p:nvPr/>
+        </p:nvSpPr>
+        <p:spPr>
+          <a:xfrm>
+            <a:off x="6400800" y="1664208"/>
+            <a:ext cx="4830775" cy="4398264"/>
+          </a:xfrm>
+          <a:prstGeom prst="rect">
+            <a:avLst/>
+          </a:prstGeom>
+          <a:noFill/>
+        </p:spPr>
+        <p:txBody>
+          <a:bodyPr wrap="square" lIns="0" rIns="0" tIns="0" bIns="0">
+            <a:spAutoFit/>
+          </a:bodyPr>
+          <a:lstStyle/>
+          <a:p>
+            <a:pPr>
+              <a:spcAft>
+                <a:spcPts val="1200"/>
+              </a:spcAft>
+              <a:defRPr sz="1550" b="1">
                 <a:solidFill>
                   <a:srgbClr val="0D9488"/>
                 </a:solidFill>
+                <a:latin typeface="Calibri"/>
               </a:defRPr>
             </a:pPr>
             <a:r>
@@ -4048,7 +4112,7 @@
           <a:p>
             <a:pPr>
               <a:spcAft>
-                <a:spcPts val="800"/>
+                <a:spcPts val="900"/>
               </a:spcAft>
             </a:pPr>
             <a:r>
@@ -4056,6 +4120,7 @@
                 <a:solidFill>
                   <a:srgbClr val="1A365D"/>
                 </a:solidFill>
+                <a:latin typeface="Calibri"/>
               </a:rPr>
               <a:t>✔ Analyzes food &amp; storage conditions</a:t>
             </a:r>
@@ -4064,6 +4129,7 @@
                 <a:solidFill>
                   <a:srgbClr val="1E293B"/>
                 </a:solidFill>
+                <a:latin typeface="Calibri"/>
               </a:rPr>
               <a:t> to identify packaging needs (water activity aw, respiration, ethylene).</a:t>
             </a:r>
@@ -4071,7 +4137,7 @@
           <a:p>
             <a:pPr>
               <a:spcAft>
-                <a:spcPts val="800"/>
+                <a:spcPts val="900"/>
               </a:spcAft>
             </a:pPr>
             <a:r>
@@ -4079,6 +4145,7 @@
                 <a:solidFill>
                   <a:srgbClr val="1A365D"/>
                 </a:solidFill>
+                <a:latin typeface="Calibri"/>
               </a:rPr>
               <a:t>✔ Recommends materials with OTR, WVTR &amp; thickness guidance</a:t>
             </a:r>
@@ -4087,6 +4154,7 @@
                 <a:solidFill>
                   <a:srgbClr val="1E293B"/>
                 </a:solidFill>
+                <a:latin typeface="Calibri"/>
               </a:rPr>
               <a:t> for hermetic barrier protection.</a:t>
             </a:r>
@@ -4094,7 +4162,7 @@
           <a:p>
             <a:pPr>
               <a:spcAft>
-                <a:spcPts val="800"/>
+                <a:spcPts val="900"/>
               </a:spcAft>
             </a:pPr>
             <a:r>
@@ -4102,6 +4170,7 @@
                 <a:solidFill>
                   <a:srgbClr val="1A365D"/>
                 </a:solidFill>
+                <a:latin typeface="Calibri"/>
               </a:rPr>
               <a:t>✔ Considers respiration, temperature &amp; humidity</a:t>
             </a:r>
@@ -4110,6 +4179,7 @@
                 <a:solidFill>
                   <a:srgbClr val="1E293B"/>
                 </a:solidFill>
+                <a:latin typeface="Calibri"/>
               </a:rPr>
               <a:t> for fresh produce to design equilibrium MAP atmospheres.</a:t>
             </a:r>
@@ -4117,7 +4187,7 @@
           <a:p>
             <a:pPr>
               <a:spcAft>
-                <a:spcPts val="800"/>
+                <a:spcPts val="900"/>
               </a:spcAft>
             </a:pPr>
             <a:r>
@@ -4125,6 +4195,7 @@
                 <a:solidFill>
                   <a:srgbClr val="1A365D"/>
                 </a:solidFill>
+                <a:latin typeface="Calibri"/>
               </a:rPr>
               <a:t>✔ Offers sustainable and cost-aware packaging alternatives</a:t>
             </a:r>
@@ -4133,6 +4204,7 @@
                 <a:solidFill>
                   <a:srgbClr val="1E293B"/>
                 </a:solidFill>
+                <a:latin typeface="Calibri"/>
               </a:rPr>
               <a:t> (marine PHA, PLA, Chitosan, circular Mono-PE/PP).</a:t>
             </a:r>
@@ -4140,7 +4212,7 @@
           <a:p>
             <a:pPr>
               <a:spcAft>
-                <a:spcPts val="800"/>
+                <a:spcPts val="900"/>
               </a:spcAft>
             </a:pPr>
             <a:r>
@@ -4148,6 +4220,7 @@
                 <a:solidFill>
                   <a:srgbClr val="1A365D"/>
                 </a:solidFill>
+                <a:latin typeface="Calibri"/>
               </a:rPr>
               <a:t>✔ Provides explainable recommendations with shelf-life estimation</a:t>
             </a:r>
@@ -4156,6 +4229,7 @@
                 <a:solidFill>
                   <a:srgbClr val="1E293B"/>
                 </a:solidFill>
+                <a:latin typeface="Calibri"/>
               </a:rPr>
               <a:t> via Arrhenius kinetic models.</a:t>
             </a:r>
@@ -4163,7 +4237,7 @@
           <a:p>
             <a:pPr>
               <a:spcAft>
-                <a:spcPts val="800"/>
+                <a:spcPts val="900"/>
               </a:spcAft>
             </a:pPr>
             <a:r>
@@ -4171,6 +4245,7 @@
                 <a:solidFill>
                   <a:srgbClr val="1A365D"/>
                 </a:solidFill>
+                <a:latin typeface="Calibri"/>
               </a:rPr>
               <a:t>✔ Automates FSSAI compliance &amp; MoFPI subsidies</a:t>
             </a:r>
@@ -4179,54 +4254,10 @@
                 <a:solidFill>
                   <a:srgbClr val="1E293B"/>
                 </a:solidFill>
+                <a:latin typeface="Calibri"/>
               </a:rPr>
               <a:t> generating printable IS 9845 dossiers and PMFME 35% grants.</a:t>
             </a:r>
-          </a:p>
-        </p:txBody>
-      </p:sp>
-      <p:sp>
-        <p:nvSpPr>
-          <p:cNvPr id="11" name="Rounded Rectangle 10"/>
-          <p:cNvSpPr/>
-          <p:nvPr/>
-        </p:nvSpPr>
-        <p:spPr>
-          <a:xfrm>
-            <a:off x="6035040" y="1554480"/>
-            <a:ext cx="5486400" cy="109728"/>
-          </a:xfrm>
-          <a:prstGeom prst="roundRect">
-            <a:avLst/>
-          </a:prstGeom>
-          <a:solidFill>
-            <a:srgbClr val="0D9488"/>
-          </a:solidFill>
-          <a:ln>
-            <a:solidFill>
-              <a:srgbClr val="0D9488"/>
-            </a:solidFill>
-          </a:ln>
-        </p:spPr>
-        <p:style>
-          <a:lnRef idx="1">
-            <a:schemeClr val="accent1"/>
-          </a:lnRef>
-          <a:fillRef idx="3">
-            <a:schemeClr val="accent1"/>
-          </a:fillRef>
-          <a:effectRef idx="2">
-            <a:schemeClr val="accent1"/>
-          </a:effectRef>
-          <a:fontRef idx="minor">
-            <a:schemeClr val="lt1"/>
-          </a:fontRef>
-        </p:style>
-        <p:txBody>
-          <a:bodyPr rtlCol="0" anchor="ctr"/>
-          <a:lstStyle/>
-          <a:p>
-            <a:pPr algn="ctr"/>
           </a:p>
         </p:txBody>
       </p:sp>
@@ -4256,8 +4287,8 @@
         </p:nvSpPr>
         <p:spPr>
           <a:xfrm>
-            <a:off x="640080" y="256032"/>
-            <a:ext cx="2926080" cy="365760"/>
+            <a:off x="731520" y="256032"/>
+            <a:ext cx="3200400" cy="365760"/>
           </a:xfrm>
           <a:prstGeom prst="rect">
             <a:avLst/>
@@ -4265,7 +4296,7 @@
           <a:noFill/>
         </p:spPr>
         <p:txBody>
-          <a:bodyPr wrap="square">
+          <a:bodyPr wrap="square" lIns="0" rIns="0" tIns="0" bIns="0">
             <a:spAutoFit/>
           </a:bodyPr>
           <a:lstStyle/>
@@ -4275,6 +4306,7 @@
                 <a:solidFill>
                   <a:srgbClr val="B91C1C"/>
                 </a:solidFill>
+                <a:latin typeface="Calibri"/>
               </a:defRPr>
             </a:pPr>
             <a:r>
@@ -4291,8 +4323,8 @@
         </p:nvSpPr>
         <p:spPr>
           <a:xfrm>
-            <a:off x="8778240" y="256032"/>
-            <a:ext cx="2743200" cy="365760"/>
+            <a:off x="8229600" y="256032"/>
+            <a:ext cx="3230575" cy="365760"/>
           </a:xfrm>
           <a:prstGeom prst="rect">
             <a:avLst/>
@@ -4300,7 +4332,7 @@
           <a:noFill/>
         </p:spPr>
         <p:txBody>
-          <a:bodyPr wrap="square">
+          <a:bodyPr wrap="square" lIns="0" rIns="0" tIns="0" bIns="0">
             <a:spAutoFit/>
           </a:bodyPr>
           <a:lstStyle/>
@@ -4310,6 +4342,7 @@
                 <a:solidFill>
                   <a:srgbClr val="1A365D"/>
                 </a:solidFill>
+                <a:latin typeface="Calibri"/>
               </a:defRPr>
             </a:pPr>
             <a:r>
@@ -4326,8 +4359,8 @@
         </p:nvSpPr>
         <p:spPr>
           <a:xfrm>
-            <a:off x="1371600" y="502920"/>
-            <a:ext cx="9445752" cy="640080"/>
+            <a:off x="914400" y="475488"/>
+            <a:ext cx="10362895" cy="640080"/>
           </a:xfrm>
           <a:prstGeom prst="rect">
             <a:avLst/>
@@ -4335,7 +4368,7 @@
           <a:noFill/>
         </p:spPr>
         <p:txBody>
-          <a:bodyPr wrap="none">
+          <a:bodyPr wrap="none" lIns="0" rIns="0" tIns="0" bIns="0">
             <a:spAutoFit/>
           </a:bodyPr>
           <a:lstStyle/>
@@ -4345,6 +4378,7 @@
                 <a:solidFill>
                   <a:srgbClr val="1A365D"/>
                 </a:solidFill>
+                <a:latin typeface="Calibri"/>
               </a:defRPr>
             </a:pPr>
             <a:r>
@@ -4425,6 +4459,7 @@
                 <a:solidFill>
                   <a:srgbClr val="FFFFFF"/>
                 </a:solidFill>
+                <a:latin typeface="Calibri"/>
               </a:defRPr>
             </a:pPr>
             <a:r>
@@ -4441,8 +4476,8 @@
         </p:nvSpPr>
         <p:spPr>
           <a:xfrm>
-            <a:off x="640080" y="1417320"/>
-            <a:ext cx="2542032" cy="4114800"/>
+            <a:off x="731520" y="1353312"/>
+            <a:ext cx="2523744" cy="4160520"/>
           </a:xfrm>
           <a:prstGeom prst="roundRect">
             <a:avLst/>
@@ -4471,153 +4506,144 @@
           </a:fontRef>
         </p:style>
         <p:txBody>
-          <a:bodyPr rtlCol="0" anchor="ctr" wrap="square" lIns="164592" rIns="164592" tIns="502920"/>
+          <a:bodyPr rtlCol="0" anchor="ctr"/>
           <a:lstStyle/>
           <a:p>
             <a:pPr algn="ctr"/>
           </a:p>
-          <a:p>
-            <a:pPr>
-              <a:spcAft>
-                <a:spcPts val="700"/>
-              </a:spcAft>
-              <a:defRPr sz="1050">
-                <a:solidFill>
-                  <a:srgbClr val="1E293B"/>
-                </a:solidFill>
-              </a:defRPr>
-            </a:pPr>
-            <a:r>
-              <a:t>✔ Water Activity (aw: 0.18 - 0.99)</a:t>
-            </a:r>
-          </a:p>
-          <a:p>
-            <a:pPr>
-              <a:spcAft>
-                <a:spcPts val="700"/>
-              </a:spcAft>
-              <a:defRPr sz="1050">
-                <a:solidFill>
-                  <a:srgbClr val="1E293B"/>
-                </a:solidFill>
-              </a:defRPr>
-            </a:pPr>
-            <a:r>
-              <a:t>✔ Respiration Rate (R_CO2)</a:t>
-            </a:r>
-          </a:p>
-          <a:p>
-            <a:pPr>
-              <a:spcAft>
-                <a:spcPts val="700"/>
-              </a:spcAft>
-              <a:defRPr sz="1050">
-                <a:solidFill>
-                  <a:srgbClr val="1E293B"/>
-                </a:solidFill>
-              </a:defRPr>
-            </a:pPr>
-            <a:r>
-              <a:t>✔ Ethylene Sensitivity Index</a:t>
-            </a:r>
-          </a:p>
-          <a:p>
-            <a:pPr>
-              <a:spcAft>
-                <a:spcPts val="700"/>
-              </a:spcAft>
-              <a:defRPr sz="1050">
-                <a:solidFill>
-                  <a:srgbClr val="1E293B"/>
-                </a:solidFill>
-              </a:defRPr>
-            </a:pPr>
-            <a:r>
-              <a:t>✔ Target Storage Temp (0°-30°C)</a:t>
-            </a:r>
-          </a:p>
-          <a:p>
-            <a:pPr>
-              <a:spcAft>
-                <a:spcPts val="700"/>
-              </a:spcAft>
-              <a:defRPr sz="1050">
-                <a:solidFill>
-                  <a:srgbClr val="1E293B"/>
-                </a:solidFill>
-              </a:defRPr>
-            </a:pPr>
-            <a:r>
-              <a:t>✔ Supply Chain RH &amp; Transit Days</a:t>
-            </a:r>
-          </a:p>
-          <a:p>
-            <a:pPr>
-              <a:spcAft>
-                <a:spcPts val="700"/>
-              </a:spcAft>
-              <a:defRPr sz="1050">
-                <a:solidFill>
-                  <a:srgbClr val="1E293B"/>
-                </a:solidFill>
-              </a:defRPr>
-            </a:pPr>
-            <a:r>
-              <a:t>✔ 24 Categorized Staples</a:t>
-            </a:r>
-          </a:p>
-        </p:txBody>
-      </p:sp>
-      <p:sp>
-        <p:nvSpPr>
-          <p:cNvPr id="8" name="Rounded Rectangle 7"/>
-          <p:cNvSpPr/>
+        </p:txBody>
+      </p:sp>
+      <p:sp>
+        <p:nvSpPr>
+          <p:cNvPr id="8" name="TextBox 7"/>
+          <p:cNvSpPr txBox="1"/>
           <p:nvPr/>
         </p:nvSpPr>
         <p:spPr>
           <a:xfrm>
-            <a:off x="640080" y="1417320"/>
-            <a:ext cx="2542032" cy="384048"/>
-          </a:xfrm>
-          <a:prstGeom prst="roundRect">
+            <a:off x="960120" y="1554480"/>
+            <a:ext cx="2066543" cy="3758183"/>
+          </a:xfrm>
+          <a:prstGeom prst="rect">
             <a:avLst/>
           </a:prstGeom>
-          <a:solidFill>
-            <a:srgbClr val="0284C7"/>
-          </a:solidFill>
-          <a:ln>
-            <a:solidFill>
-              <a:srgbClr val="0284C7"/>
-            </a:solidFill>
-          </a:ln>
-        </p:spPr>
-        <p:style>
-          <a:lnRef idx="1">
-            <a:schemeClr val="accent1"/>
-          </a:lnRef>
-          <a:fillRef idx="3">
-            <a:schemeClr val="accent1"/>
-          </a:fillRef>
-          <a:effectRef idx="2">
-            <a:schemeClr val="accent1"/>
-          </a:effectRef>
-          <a:fontRef idx="minor">
-            <a:schemeClr val="lt1"/>
-          </a:fontRef>
-        </p:style>
-        <p:txBody>
-          <a:bodyPr rtlCol="0" anchor="ctr"/>
-          <a:lstStyle/>
-          <a:p>
-            <a:pPr algn="ctr">
-              <a:defRPr sz="1100" b="1">
-                <a:solidFill>
-                  <a:srgbClr val="FFFFFF"/>
-                </a:solidFill>
+          <a:noFill/>
+        </p:spPr>
+        <p:txBody>
+          <a:bodyPr wrap="square" lIns="0" rIns="0" tIns="0" bIns="0">
+            <a:spAutoFit/>
+          </a:bodyPr>
+          <a:lstStyle/>
+          <a:p>
+            <a:pPr>
+              <a:spcAft>
+                <a:spcPts val="1000"/>
+              </a:spcAft>
+              <a:defRPr sz="1200" b="1">
+                <a:solidFill>
+                  <a:srgbClr val="0284C7"/>
+                </a:solidFill>
+                <a:latin typeface="Calibri"/>
               </a:defRPr>
             </a:pPr>
             <a:r>
               <a:t>STEP 01 : Biochemical Input</a:t>
+            </a:r>
+          </a:p>
+          <a:p>
+            <a:pPr>
+              <a:spcAft>
+                <a:spcPts val="600"/>
+              </a:spcAft>
+              <a:defRPr sz="1050">
+                <a:solidFill>
+                  <a:srgbClr val="1E293B"/>
+                </a:solidFill>
+                <a:latin typeface="Calibri"/>
+              </a:defRPr>
+            </a:pPr>
+            <a:r>
+              <a:t>✔ Water Activity (aw: 0.18 - 0.99)</a:t>
+            </a:r>
+          </a:p>
+          <a:p>
+            <a:pPr>
+              <a:spcAft>
+                <a:spcPts val="600"/>
+              </a:spcAft>
+              <a:defRPr sz="1050">
+                <a:solidFill>
+                  <a:srgbClr val="1E293B"/>
+                </a:solidFill>
+                <a:latin typeface="Calibri"/>
+              </a:defRPr>
+            </a:pPr>
+            <a:r>
+              <a:t>✔ Respiration Rate (R_CO2)</a:t>
+            </a:r>
+          </a:p>
+          <a:p>
+            <a:pPr>
+              <a:spcAft>
+                <a:spcPts val="600"/>
+              </a:spcAft>
+              <a:defRPr sz="1050">
+                <a:solidFill>
+                  <a:srgbClr val="1E293B"/>
+                </a:solidFill>
+                <a:latin typeface="Calibri"/>
+              </a:defRPr>
+            </a:pPr>
+            <a:r>
+              <a:t>✔ Ethylene Sensitivity Index</a:t>
+            </a:r>
+          </a:p>
+          <a:p>
+            <a:pPr>
+              <a:spcAft>
+                <a:spcPts val="600"/>
+              </a:spcAft>
+              <a:defRPr sz="1050">
+                <a:solidFill>
+                  <a:srgbClr val="1E293B"/>
+                </a:solidFill>
+                <a:latin typeface="Calibri"/>
+              </a:defRPr>
+            </a:pPr>
+            <a:r>
+              <a:t>✔ Target Storage Temp (0°-30°C)</a:t>
+            </a:r>
+          </a:p>
+          <a:p>
+            <a:pPr>
+              <a:spcAft>
+                <a:spcPts val="600"/>
+              </a:spcAft>
+              <a:defRPr sz="1050">
+                <a:solidFill>
+                  <a:srgbClr val="1E293B"/>
+                </a:solidFill>
+                <a:latin typeface="Calibri"/>
+              </a:defRPr>
+            </a:pPr>
+            <a:r>
+              <a:t>✔ Supply Chain RH &amp; Transit Days</a:t>
+            </a:r>
+          </a:p>
+          <a:p>
+            <a:pPr>
+              <a:spcAft>
+                <a:spcPts val="600"/>
+              </a:spcAft>
+              <a:defRPr sz="1050">
+                <a:solidFill>
+                  <a:srgbClr val="1E293B"/>
+                </a:solidFill>
+                <a:latin typeface="Calibri"/>
+              </a:defRPr>
+            </a:pPr>
+            <a:r>
+              <a:t>✔ 24 Categorized Indian Staples</a:t>
             </a:r>
           </a:p>
         </p:txBody>
@@ -4630,8 +4656,8 @@
         </p:nvSpPr>
         <p:spPr>
           <a:xfrm>
-            <a:off x="3401568" y="1417320"/>
-            <a:ext cx="2542032" cy="4114800"/>
+            <a:off x="3465576" y="1353312"/>
+            <a:ext cx="2523744" cy="4160520"/>
           </a:xfrm>
           <a:prstGeom prst="roundRect">
             <a:avLst/>
@@ -4660,153 +4686,144 @@
           </a:fontRef>
         </p:style>
         <p:txBody>
-          <a:bodyPr rtlCol="0" anchor="ctr" wrap="square" lIns="164592" rIns="164592" tIns="502920"/>
+          <a:bodyPr rtlCol="0" anchor="ctr"/>
           <a:lstStyle/>
           <a:p>
             <a:pPr algn="ctr"/>
           </a:p>
-          <a:p>
-            <a:pPr>
-              <a:spcAft>
-                <a:spcPts val="700"/>
-              </a:spcAft>
-              <a:defRPr sz="1050">
-                <a:solidFill>
-                  <a:srgbClr val="1E293B"/>
-                </a:solidFill>
-              </a:defRPr>
-            </a:pPr>
-            <a:r>
-              <a:t>✔ Calculates OTR (&lt;1 to &gt;5000 cm³/m²·d)</a:t>
-            </a:r>
-          </a:p>
-          <a:p>
-            <a:pPr>
-              <a:spcAft>
-                <a:spcPts val="700"/>
-              </a:spcAft>
-              <a:defRPr sz="1050">
-                <a:solidFill>
-                  <a:srgbClr val="1E293B"/>
-                </a:solidFill>
-              </a:defRPr>
-            </a:pPr>
-            <a:r>
-              <a:t>✔ Calculates WVTR (&lt;0.1 to &gt;50 g/m²·d)</a:t>
-            </a:r>
-          </a:p>
-          <a:p>
-            <a:pPr>
-              <a:spcAft>
-                <a:spcPts val="700"/>
-              </a:spcAft>
-              <a:defRPr sz="1050">
-                <a:solidFill>
-                  <a:srgbClr val="1E293B"/>
-                </a:solidFill>
-              </a:defRPr>
-            </a:pPr>
-            <a:r>
-              <a:t>✔ Active Tech (KMnO4, nisin pads)</a:t>
-            </a:r>
-          </a:p>
-          <a:p>
-            <a:pPr>
-              <a:spcAft>
-                <a:spcPts val="700"/>
-              </a:spcAft>
-              <a:defRPr sz="1050">
-                <a:solidFill>
-                  <a:srgbClr val="1E293B"/>
-                </a:solidFill>
-              </a:defRPr>
-            </a:pPr>
-            <a:r>
-              <a:t>✔ Bio-Polymer Multi-Attribute Filtering</a:t>
-            </a:r>
-          </a:p>
-          <a:p>
-            <a:pPr>
-              <a:spcAft>
-                <a:spcPts val="700"/>
-              </a:spcAft>
-              <a:defRPr sz="1050">
-                <a:solidFill>
-                  <a:srgbClr val="1E293B"/>
-                </a:solidFill>
-              </a:defRPr>
-            </a:pPr>
-            <a:r>
-              <a:t>✔ Recyclable Mono-materials fallback</a:t>
-            </a:r>
-          </a:p>
-          <a:p>
-            <a:pPr>
-              <a:spcAft>
-                <a:spcPts val="700"/>
-              </a:spcAft>
-              <a:defRPr sz="1050">
-                <a:solidFill>
-                  <a:srgbClr val="1E293B"/>
-                </a:solidFill>
-              </a:defRPr>
-            </a:pPr>
-            <a:r>
-              <a:t>✔ Packaging Gauge &amp; Sealing Rules</a:t>
-            </a:r>
-          </a:p>
-        </p:txBody>
-      </p:sp>
-      <p:sp>
-        <p:nvSpPr>
-          <p:cNvPr id="10" name="Rounded Rectangle 9"/>
-          <p:cNvSpPr/>
+        </p:txBody>
+      </p:sp>
+      <p:sp>
+        <p:nvSpPr>
+          <p:cNvPr id="10" name="TextBox 9"/>
+          <p:cNvSpPr txBox="1"/>
           <p:nvPr/>
         </p:nvSpPr>
         <p:spPr>
           <a:xfrm>
-            <a:off x="3401568" y="1417320"/>
-            <a:ext cx="2542032" cy="384048"/>
-          </a:xfrm>
-          <a:prstGeom prst="roundRect">
+            <a:off x="3694176" y="1554480"/>
+            <a:ext cx="2066543" cy="3758183"/>
+          </a:xfrm>
+          <a:prstGeom prst="rect">
             <a:avLst/>
           </a:prstGeom>
-          <a:solidFill>
-            <a:srgbClr val="0D9488"/>
-          </a:solidFill>
-          <a:ln>
-            <a:solidFill>
-              <a:srgbClr val="0D9488"/>
-            </a:solidFill>
-          </a:ln>
-        </p:spPr>
-        <p:style>
-          <a:lnRef idx="1">
-            <a:schemeClr val="accent1"/>
-          </a:lnRef>
-          <a:fillRef idx="3">
-            <a:schemeClr val="accent1"/>
-          </a:fillRef>
-          <a:effectRef idx="2">
-            <a:schemeClr val="accent1"/>
-          </a:effectRef>
-          <a:fontRef idx="minor">
-            <a:schemeClr val="lt1"/>
-          </a:fontRef>
-        </p:style>
-        <p:txBody>
-          <a:bodyPr rtlCol="0" anchor="ctr"/>
-          <a:lstStyle/>
-          <a:p>
-            <a:pPr algn="ctr">
-              <a:defRPr sz="1100" b="1">
-                <a:solidFill>
-                  <a:srgbClr val="FFFFFF"/>
-                </a:solidFill>
+          <a:noFill/>
+        </p:spPr>
+        <p:txBody>
+          <a:bodyPr wrap="square" lIns="0" rIns="0" tIns="0" bIns="0">
+            <a:spAutoFit/>
+          </a:bodyPr>
+          <a:lstStyle/>
+          <a:p>
+            <a:pPr>
+              <a:spcAft>
+                <a:spcPts val="1000"/>
+              </a:spcAft>
+              <a:defRPr sz="1200" b="1">
+                <a:solidFill>
+                  <a:srgbClr val="0D9488"/>
+                </a:solidFill>
+                <a:latin typeface="Calibri"/>
               </a:defRPr>
             </a:pPr>
             <a:r>
               <a:t>STEP 02 : Dual-Barrier Engine</a:t>
+            </a:r>
+          </a:p>
+          <a:p>
+            <a:pPr>
+              <a:spcAft>
+                <a:spcPts val="600"/>
+              </a:spcAft>
+              <a:defRPr sz="1050">
+                <a:solidFill>
+                  <a:srgbClr val="1E293B"/>
+                </a:solidFill>
+                <a:latin typeface="Calibri"/>
+              </a:defRPr>
+            </a:pPr>
+            <a:r>
+              <a:t>✔ Target OTR (&lt;1 to &gt;5000 cm³/m²·d)</a:t>
+            </a:r>
+          </a:p>
+          <a:p>
+            <a:pPr>
+              <a:spcAft>
+                <a:spcPts val="600"/>
+              </a:spcAft>
+              <a:defRPr sz="1050">
+                <a:solidFill>
+                  <a:srgbClr val="1E293B"/>
+                </a:solidFill>
+                <a:latin typeface="Calibri"/>
+              </a:defRPr>
+            </a:pPr>
+            <a:r>
+              <a:t>✔ Target WVTR (&lt;0.1 to &gt;50 g/m²·d)</a:t>
+            </a:r>
+          </a:p>
+          <a:p>
+            <a:pPr>
+              <a:spcAft>
+                <a:spcPts val="600"/>
+              </a:spcAft>
+              <a:defRPr sz="1050">
+                <a:solidFill>
+                  <a:srgbClr val="1E293B"/>
+                </a:solidFill>
+                <a:latin typeface="Calibri"/>
+              </a:defRPr>
+            </a:pPr>
+            <a:r>
+              <a:t>✔ Active Tech (KMnO4, nisin pads)</a:t>
+            </a:r>
+          </a:p>
+          <a:p>
+            <a:pPr>
+              <a:spcAft>
+                <a:spcPts val="600"/>
+              </a:spcAft>
+              <a:defRPr sz="1050">
+                <a:solidFill>
+                  <a:srgbClr val="1E293B"/>
+                </a:solidFill>
+                <a:latin typeface="Calibri"/>
+              </a:defRPr>
+            </a:pPr>
+            <a:r>
+              <a:t>✔ Bio-Polymer Multi-Attribute Filter</a:t>
+            </a:r>
+          </a:p>
+          <a:p>
+            <a:pPr>
+              <a:spcAft>
+                <a:spcPts val="600"/>
+              </a:spcAft>
+              <a:defRPr sz="1050">
+                <a:solidFill>
+                  <a:srgbClr val="1E293B"/>
+                </a:solidFill>
+                <a:latin typeface="Calibri"/>
+              </a:defRPr>
+            </a:pPr>
+            <a:r>
+              <a:t>✔ Recyclable Mono-materials fallback</a:t>
+            </a:r>
+          </a:p>
+          <a:p>
+            <a:pPr>
+              <a:spcAft>
+                <a:spcPts val="600"/>
+              </a:spcAft>
+              <a:defRPr sz="1050">
+                <a:solidFill>
+                  <a:srgbClr val="1E293B"/>
+                </a:solidFill>
+                <a:latin typeface="Calibri"/>
+              </a:defRPr>
+            </a:pPr>
+            <a:r>
+              <a:t>✔ Packaging Gauge &amp; Sealing Rules</a:t>
             </a:r>
           </a:p>
         </p:txBody>
@@ -4819,8 +4836,8 @@
         </p:nvSpPr>
         <p:spPr>
           <a:xfrm>
-            <a:off x="6163056" y="1417320"/>
-            <a:ext cx="2542032" cy="4114800"/>
+            <a:off x="6199631" y="1353312"/>
+            <a:ext cx="2523744" cy="4160520"/>
           </a:xfrm>
           <a:prstGeom prst="roundRect">
             <a:avLst/>
@@ -4849,153 +4866,144 @@
           </a:fontRef>
         </p:style>
         <p:txBody>
-          <a:bodyPr rtlCol="0" anchor="ctr" wrap="square" lIns="164592" rIns="164592" tIns="502920"/>
+          <a:bodyPr rtlCol="0" anchor="ctr"/>
           <a:lstStyle/>
           <a:p>
             <a:pPr algn="ctr"/>
           </a:p>
-          <a:p>
-            <a:pPr>
-              <a:spcAft>
-                <a:spcPts val="700"/>
-              </a:spcAft>
-              <a:defRPr sz="1050">
-                <a:solidFill>
-                  <a:srgbClr val="1E293B"/>
-                </a:solidFill>
-              </a:defRPr>
-            </a:pPr>
-            <a:r>
-              <a:t>✔ Arrhenius Model: k = A·exp(-Ea/RT)</a:t>
-            </a:r>
-          </a:p>
-          <a:p>
-            <a:pPr>
-              <a:spcAft>
-                <a:spcPts val="700"/>
-              </a:spcAft>
-              <a:defRPr sz="1050">
-                <a:solidFill>
-                  <a:srgbClr val="1E293B"/>
-                </a:solidFill>
-              </a:defRPr>
-            </a:pPr>
-            <a:r>
-              <a:t>✔ Q10 Temp Quotient (2.0 - 2.8x)</a:t>
-            </a:r>
-          </a:p>
-          <a:p>
-            <a:pPr>
-              <a:spcAft>
-                <a:spcPts val="700"/>
-              </a:spcAft>
-              <a:defRPr sz="1050">
-                <a:solidFill>
-                  <a:srgbClr val="1E293B"/>
-                </a:solidFill>
-              </a:defRPr>
-            </a:pPr>
-            <a:r>
-              <a:t>✔ Cold-Chain Rupture Stress Test</a:t>
-            </a:r>
-          </a:p>
-          <a:p>
-            <a:pPr>
-              <a:spcAft>
-                <a:spcPts val="700"/>
-              </a:spcAft>
-              <a:defRPr sz="1050">
-                <a:solidFill>
-                  <a:srgbClr val="1E293B"/>
-                </a:solidFill>
-              </a:defRPr>
-            </a:pPr>
-            <a:r>
-              <a:t>✔ Equilibrium MAP Gas Flush</a:t>
-            </a:r>
-          </a:p>
-          <a:p>
-            <a:pPr>
-              <a:spcAft>
-                <a:spcPts val="700"/>
-              </a:spcAft>
-              <a:defRPr sz="1050">
-                <a:solidFill>
-                  <a:srgbClr val="1E293B"/>
-                </a:solidFill>
-              </a:defRPr>
-            </a:pPr>
-            <a:r>
-              <a:t>✔ Shelf-Life Expansion (+150%-450%)</a:t>
-            </a:r>
-          </a:p>
-          <a:p>
-            <a:pPr>
-              <a:spcAft>
-                <a:spcPts val="700"/>
-              </a:spcAft>
-              <a:defRPr sz="1050">
-                <a:solidFill>
-                  <a:srgbClr val="1E293B"/>
-                </a:solidFill>
-              </a:defRPr>
-            </a:pPr>
-            <a:r>
-              <a:t>✔ Dynamic Spoilage Curves</a:t>
-            </a:r>
-          </a:p>
-        </p:txBody>
-      </p:sp>
-      <p:sp>
-        <p:nvSpPr>
-          <p:cNvPr id="12" name="Rounded Rectangle 11"/>
-          <p:cNvSpPr/>
+        </p:txBody>
+      </p:sp>
+      <p:sp>
+        <p:nvSpPr>
+          <p:cNvPr id="12" name="TextBox 11"/>
+          <p:cNvSpPr txBox="1"/>
           <p:nvPr/>
         </p:nvSpPr>
         <p:spPr>
           <a:xfrm>
-            <a:off x="6163056" y="1417320"/>
-            <a:ext cx="2542032" cy="384048"/>
-          </a:xfrm>
-          <a:prstGeom prst="roundRect">
+            <a:off x="6428231" y="1554480"/>
+            <a:ext cx="2066543" cy="3758183"/>
+          </a:xfrm>
+          <a:prstGeom prst="rect">
             <a:avLst/>
           </a:prstGeom>
-          <a:solidFill>
-            <a:srgbClr val="D97706"/>
-          </a:solidFill>
-          <a:ln>
-            <a:solidFill>
-              <a:srgbClr val="D97706"/>
-            </a:solidFill>
-          </a:ln>
-        </p:spPr>
-        <p:style>
-          <a:lnRef idx="1">
-            <a:schemeClr val="accent1"/>
-          </a:lnRef>
-          <a:fillRef idx="3">
-            <a:schemeClr val="accent1"/>
-          </a:fillRef>
-          <a:effectRef idx="2">
-            <a:schemeClr val="accent1"/>
-          </a:effectRef>
-          <a:fontRef idx="minor">
-            <a:schemeClr val="lt1"/>
-          </a:fontRef>
-        </p:style>
-        <p:txBody>
-          <a:bodyPr rtlCol="0" anchor="ctr"/>
-          <a:lstStyle/>
-          <a:p>
-            <a:pPr algn="ctr">
-              <a:defRPr sz="1100" b="1">
-                <a:solidFill>
-                  <a:srgbClr val="FFFFFF"/>
-                </a:solidFill>
+          <a:noFill/>
+        </p:spPr>
+        <p:txBody>
+          <a:bodyPr wrap="square" lIns="0" rIns="0" tIns="0" bIns="0">
+            <a:spAutoFit/>
+          </a:bodyPr>
+          <a:lstStyle/>
+          <a:p>
+            <a:pPr>
+              <a:spcAft>
+                <a:spcPts val="1000"/>
+              </a:spcAft>
+              <a:defRPr sz="1200" b="1">
+                <a:solidFill>
+                  <a:srgbClr val="D97706"/>
+                </a:solidFill>
+                <a:latin typeface="Calibri"/>
               </a:defRPr>
             </a:pPr>
             <a:r>
               <a:t>STEP 03 : Kinetic Simulation</a:t>
+            </a:r>
+          </a:p>
+          <a:p>
+            <a:pPr>
+              <a:spcAft>
+                <a:spcPts val="600"/>
+              </a:spcAft>
+              <a:defRPr sz="1050">
+                <a:solidFill>
+                  <a:srgbClr val="1E293B"/>
+                </a:solidFill>
+                <a:latin typeface="Calibri"/>
+              </a:defRPr>
+            </a:pPr>
+            <a:r>
+              <a:t>✔ Arrhenius Model: k = A·exp(-Ea/RT)</a:t>
+            </a:r>
+          </a:p>
+          <a:p>
+            <a:pPr>
+              <a:spcAft>
+                <a:spcPts val="600"/>
+              </a:spcAft>
+              <a:defRPr sz="1050">
+                <a:solidFill>
+                  <a:srgbClr val="1E293B"/>
+                </a:solidFill>
+                <a:latin typeface="Calibri"/>
+              </a:defRPr>
+            </a:pPr>
+            <a:r>
+              <a:t>✔ Q10 Temp Quotient (2.0 - 2.8x)</a:t>
+            </a:r>
+          </a:p>
+          <a:p>
+            <a:pPr>
+              <a:spcAft>
+                <a:spcPts val="600"/>
+              </a:spcAft>
+              <a:defRPr sz="1050">
+                <a:solidFill>
+                  <a:srgbClr val="1E293B"/>
+                </a:solidFill>
+                <a:latin typeface="Calibri"/>
+              </a:defRPr>
+            </a:pPr>
+            <a:r>
+              <a:t>✔ Cold-Chain Rupture Stress Test</a:t>
+            </a:r>
+          </a:p>
+          <a:p>
+            <a:pPr>
+              <a:spcAft>
+                <a:spcPts val="600"/>
+              </a:spcAft>
+              <a:defRPr sz="1050">
+                <a:solidFill>
+                  <a:srgbClr val="1E293B"/>
+                </a:solidFill>
+                <a:latin typeface="Calibri"/>
+              </a:defRPr>
+            </a:pPr>
+            <a:r>
+              <a:t>✔ Equilibrium MAP Gas Flush</a:t>
+            </a:r>
+          </a:p>
+          <a:p>
+            <a:pPr>
+              <a:spcAft>
+                <a:spcPts val="600"/>
+              </a:spcAft>
+              <a:defRPr sz="1050">
+                <a:solidFill>
+                  <a:srgbClr val="1E293B"/>
+                </a:solidFill>
+                <a:latin typeface="Calibri"/>
+              </a:defRPr>
+            </a:pPr>
+            <a:r>
+              <a:t>✔ Shelf-Life Multiplier (+150%-450%)</a:t>
+            </a:r>
+          </a:p>
+          <a:p>
+            <a:pPr>
+              <a:spcAft>
+                <a:spcPts val="600"/>
+              </a:spcAft>
+              <a:defRPr sz="1050">
+                <a:solidFill>
+                  <a:srgbClr val="1E293B"/>
+                </a:solidFill>
+                <a:latin typeface="Calibri"/>
+              </a:defRPr>
+            </a:pPr>
+            <a:r>
+              <a:t>✔ Dynamic Spoilage Curves</a:t>
             </a:r>
           </a:p>
         </p:txBody>
@@ -5008,8 +5016,8 @@
         </p:nvSpPr>
         <p:spPr>
           <a:xfrm>
-            <a:off x="8924544" y="1417320"/>
-            <a:ext cx="2542032" cy="4114800"/>
+            <a:off x="8933688" y="1353312"/>
+            <a:ext cx="2523744" cy="4160520"/>
           </a:xfrm>
           <a:prstGeom prst="roundRect">
             <a:avLst/>
@@ -5038,153 +5046,144 @@
           </a:fontRef>
         </p:style>
         <p:txBody>
-          <a:bodyPr rtlCol="0" anchor="ctr" wrap="square" lIns="164592" rIns="164592" tIns="502920"/>
+          <a:bodyPr rtlCol="0" anchor="ctr"/>
           <a:lstStyle/>
           <a:p>
             <a:pPr algn="ctr"/>
           </a:p>
-          <a:p>
-            <a:pPr>
-              <a:spcAft>
-                <a:spcPts val="700"/>
-              </a:spcAft>
-              <a:defRPr sz="1050">
-                <a:solidFill>
-                  <a:srgbClr val="1E293B"/>
-                </a:solidFill>
-              </a:defRPr>
-            </a:pPr>
-            <a:r>
-              <a:t>✔ FSSAI IS 9845 Migration Check</a:t>
-            </a:r>
-          </a:p>
-          <a:p>
-            <a:pPr>
-              <a:spcAft>
-                <a:spcPts val="700"/>
-              </a:spcAft>
-              <a:defRPr sz="1050">
-                <a:solidFill>
-                  <a:srgbClr val="1E293B"/>
-                </a:solidFill>
-              </a:defRPr>
-            </a:pPr>
-            <a:r>
-              <a:t>✔ Overall Migration &lt; 60 mg/kg</a:t>
-            </a:r>
-          </a:p>
-          <a:p>
-            <a:pPr>
-              <a:spcAft>
-                <a:spcPts val="700"/>
-              </a:spcAft>
-              <a:defRPr sz="1050">
-                <a:solidFill>
-                  <a:srgbClr val="1E293B"/>
-                </a:solidFill>
-              </a:defRPr>
-            </a:pPr>
-            <a:r>
-              <a:t>✔ CPCB EPR Category I-IV Validation</a:t>
-            </a:r>
-          </a:p>
-          <a:p>
-            <a:pPr>
-              <a:spcAft>
-                <a:spcPts val="700"/>
-              </a:spcAft>
-              <a:defRPr sz="1050">
-                <a:solidFill>
-                  <a:srgbClr val="1E293B"/>
-                </a:solidFill>
-              </a:defRPr>
-            </a:pPr>
-            <a:r>
-              <a:t>✔ MoFPI PMFME 35% Capital Grant</a:t>
-            </a:r>
-          </a:p>
-          <a:p>
-            <a:pPr>
-              <a:spcAft>
-                <a:spcPts val="700"/>
-              </a:spcAft>
-              <a:defRPr sz="1050">
-                <a:solidFill>
-                  <a:srgbClr val="1E293B"/>
-                </a:solidFill>
-              </a:defRPr>
-            </a:pPr>
-            <a:r>
-              <a:t>✔ Printable Technical Dossier</a:t>
-            </a:r>
-          </a:p>
-          <a:p>
-            <a:pPr>
-              <a:spcAft>
-                <a:spcPts val="700"/>
-              </a:spcAft>
-              <a:defRPr sz="1050">
-                <a:solidFill>
-                  <a:srgbClr val="1E293B"/>
-                </a:solidFill>
-              </a:defRPr>
-            </a:pPr>
-            <a:r>
-              <a:t>✔ QR-Based Batch Traceability</a:t>
-            </a:r>
-          </a:p>
-        </p:txBody>
-      </p:sp>
-      <p:sp>
-        <p:nvSpPr>
-          <p:cNvPr id="14" name="Rounded Rectangle 13"/>
-          <p:cNvSpPr/>
+        </p:txBody>
+      </p:sp>
+      <p:sp>
+        <p:nvSpPr>
+          <p:cNvPr id="14" name="TextBox 13"/>
+          <p:cNvSpPr txBox="1"/>
           <p:nvPr/>
         </p:nvSpPr>
         <p:spPr>
           <a:xfrm>
-            <a:off x="8924544" y="1417320"/>
-            <a:ext cx="2542032" cy="384048"/>
-          </a:xfrm>
-          <a:prstGeom prst="roundRect">
+            <a:off x="9162288" y="1554480"/>
+            <a:ext cx="2066543" cy="3758183"/>
+          </a:xfrm>
+          <a:prstGeom prst="rect">
             <a:avLst/>
           </a:prstGeom>
-          <a:solidFill>
-            <a:srgbClr val="1A365D"/>
-          </a:solidFill>
-          <a:ln>
-            <a:solidFill>
-              <a:srgbClr val="1A365D"/>
-            </a:solidFill>
-          </a:ln>
-        </p:spPr>
-        <p:style>
-          <a:lnRef idx="1">
-            <a:schemeClr val="accent1"/>
-          </a:lnRef>
-          <a:fillRef idx="3">
-            <a:schemeClr val="accent1"/>
-          </a:fillRef>
-          <a:effectRef idx="2">
-            <a:schemeClr val="accent1"/>
-          </a:effectRef>
-          <a:fontRef idx="minor">
-            <a:schemeClr val="lt1"/>
-          </a:fontRef>
-        </p:style>
-        <p:txBody>
-          <a:bodyPr rtlCol="0" anchor="ctr"/>
-          <a:lstStyle/>
-          <a:p>
-            <a:pPr algn="ctr">
-              <a:defRPr sz="1100" b="1">
-                <a:solidFill>
-                  <a:srgbClr val="FFFFFF"/>
-                </a:solidFill>
+          <a:noFill/>
+        </p:spPr>
+        <p:txBody>
+          <a:bodyPr wrap="square" lIns="0" rIns="0" tIns="0" bIns="0">
+            <a:spAutoFit/>
+          </a:bodyPr>
+          <a:lstStyle/>
+          <a:p>
+            <a:pPr>
+              <a:spcAft>
+                <a:spcPts val="1000"/>
+              </a:spcAft>
+              <a:defRPr sz="1200" b="1">
+                <a:solidFill>
+                  <a:srgbClr val="1A365D"/>
+                </a:solidFill>
+                <a:latin typeface="Calibri"/>
               </a:defRPr>
             </a:pPr>
             <a:r>
               <a:t>STEP 04 : Compliance &amp; Grants</a:t>
+            </a:r>
+          </a:p>
+          <a:p>
+            <a:pPr>
+              <a:spcAft>
+                <a:spcPts val="600"/>
+              </a:spcAft>
+              <a:defRPr sz="1050">
+                <a:solidFill>
+                  <a:srgbClr val="1E293B"/>
+                </a:solidFill>
+                <a:latin typeface="Calibri"/>
+              </a:defRPr>
+            </a:pPr>
+            <a:r>
+              <a:t>✔ FSSAI IS 9845 Migration Check</a:t>
+            </a:r>
+          </a:p>
+          <a:p>
+            <a:pPr>
+              <a:spcAft>
+                <a:spcPts val="600"/>
+              </a:spcAft>
+              <a:defRPr sz="1050">
+                <a:solidFill>
+                  <a:srgbClr val="1E293B"/>
+                </a:solidFill>
+                <a:latin typeface="Calibri"/>
+              </a:defRPr>
+            </a:pPr>
+            <a:r>
+              <a:t>✔ Overall Migration &lt; 60 mg/kg</a:t>
+            </a:r>
+          </a:p>
+          <a:p>
+            <a:pPr>
+              <a:spcAft>
+                <a:spcPts val="600"/>
+              </a:spcAft>
+              <a:defRPr sz="1050">
+                <a:solidFill>
+                  <a:srgbClr val="1E293B"/>
+                </a:solidFill>
+                <a:latin typeface="Calibri"/>
+              </a:defRPr>
+            </a:pPr>
+            <a:r>
+              <a:t>✔ CPCB EPR Category I-IV Validation</a:t>
+            </a:r>
+          </a:p>
+          <a:p>
+            <a:pPr>
+              <a:spcAft>
+                <a:spcPts val="600"/>
+              </a:spcAft>
+              <a:defRPr sz="1050">
+                <a:solidFill>
+                  <a:srgbClr val="1E293B"/>
+                </a:solidFill>
+                <a:latin typeface="Calibri"/>
+              </a:defRPr>
+            </a:pPr>
+            <a:r>
+              <a:t>✔ MoFPI PMFME 35% Capital Grant</a:t>
+            </a:r>
+          </a:p>
+          <a:p>
+            <a:pPr>
+              <a:spcAft>
+                <a:spcPts val="600"/>
+              </a:spcAft>
+              <a:defRPr sz="1050">
+                <a:solidFill>
+                  <a:srgbClr val="1E293B"/>
+                </a:solidFill>
+                <a:latin typeface="Calibri"/>
+              </a:defRPr>
+            </a:pPr>
+            <a:r>
+              <a:t>✔ Printable Technical Dossier</a:t>
+            </a:r>
+          </a:p>
+          <a:p>
+            <a:pPr>
+              <a:spcAft>
+                <a:spcPts val="600"/>
+              </a:spcAft>
+              <a:defRPr sz="1050">
+                <a:solidFill>
+                  <a:srgbClr val="1E293B"/>
+                </a:solidFill>
+                <a:latin typeface="Calibri"/>
+              </a:defRPr>
+            </a:pPr>
+            <a:r>
+              <a:t>✔ QR-Based Batch Traceability</a:t>
             </a:r>
           </a:p>
         </p:txBody>
@@ -5197,8 +5196,8 @@
         </p:nvSpPr>
         <p:spPr>
           <a:xfrm>
-            <a:off x="640080" y="5669280"/>
-            <a:ext cx="10908792" cy="685800"/>
+            <a:off x="731520" y="5650992"/>
+            <a:ext cx="10728655" cy="713232"/>
           </a:xfrm>
           <a:prstGeom prst="roundRect">
             <a:avLst/>
@@ -5206,9 +5205,9 @@
           <a:solidFill>
             <a:srgbClr val="F1F5F9"/>
           </a:solidFill>
-          <a:ln>
+          <a:ln w="12700">
             <a:solidFill>
-              <a:srgbClr val="E2E8F0"/>
+              <a:srgbClr val="CBD5E1"/>
             </a:solidFill>
           </a:ln>
         </p:spPr>
@@ -5227,14 +5226,41 @@
           </a:fontRef>
         </p:style>
         <p:txBody>
-          <a:bodyPr rtlCol="0" anchor="ctr" lIns="274320" tIns="109728"/>
-          <a:lstStyle/>
-          <a:p>
-            <a:pPr algn="ctr">
+          <a:bodyPr rtlCol="0" anchor="ctr"/>
+          <a:lstStyle/>
+          <a:p>
+            <a:pPr algn="ctr"/>
+          </a:p>
+        </p:txBody>
+      </p:sp>
+      <p:sp>
+        <p:nvSpPr>
+          <p:cNvPr id="16" name="TextBox 15"/>
+          <p:cNvSpPr txBox="1"/>
+          <p:nvPr/>
+        </p:nvSpPr>
+        <p:spPr>
+          <a:xfrm>
+            <a:off x="960120" y="5852159"/>
+            <a:ext cx="10271455" cy="310896"/>
+          </a:xfrm>
+          <a:prstGeom prst="rect">
+            <a:avLst/>
+          </a:prstGeom>
+          <a:noFill/>
+        </p:spPr>
+        <p:txBody>
+          <a:bodyPr wrap="square" lIns="0" rIns="0" tIns="0" bIns="0">
+            <a:spAutoFit/>
+          </a:bodyPr>
+          <a:lstStyle/>
+          <a:p>
+            <a:pPr>
               <a:defRPr b="1" sz="1100">
                 <a:solidFill>
                   <a:srgbClr val="1A365D"/>
                 </a:solidFill>
+                <a:latin typeface="Calibri"/>
               </a:defRPr>
             </a:pPr>
             <a:r>
@@ -5247,6 +5273,7 @@
                 <a:solidFill>
                   <a:srgbClr val="64748B"/>
                 </a:solidFill>
+                <a:latin typeface="Calibri"/>
               </a:defRPr>
             </a:pPr>
             <a:r>
@@ -5281,8 +5308,8 @@
         </p:nvSpPr>
         <p:spPr>
           <a:xfrm>
-            <a:off x="640080" y="256032"/>
-            <a:ext cx="2926080" cy="365760"/>
+            <a:off x="731520" y="256032"/>
+            <a:ext cx="3200400" cy="365760"/>
           </a:xfrm>
           <a:prstGeom prst="rect">
             <a:avLst/>
@@ -5290,7 +5317,7 @@
           <a:noFill/>
         </p:spPr>
         <p:txBody>
-          <a:bodyPr wrap="square">
+          <a:bodyPr wrap="square" lIns="0" rIns="0" tIns="0" bIns="0">
             <a:spAutoFit/>
           </a:bodyPr>
           <a:lstStyle/>
@@ -5300,6 +5327,7 @@
                 <a:solidFill>
                   <a:srgbClr val="B91C1C"/>
                 </a:solidFill>
+                <a:latin typeface="Calibri"/>
               </a:defRPr>
             </a:pPr>
             <a:r>
@@ -5316,8 +5344,8 @@
         </p:nvSpPr>
         <p:spPr>
           <a:xfrm>
-            <a:off x="8778240" y="256032"/>
-            <a:ext cx="2743200" cy="365760"/>
+            <a:off x="8229600" y="256032"/>
+            <a:ext cx="3230575" cy="365760"/>
           </a:xfrm>
           <a:prstGeom prst="rect">
             <a:avLst/>
@@ -5325,7 +5353,7 @@
           <a:noFill/>
         </p:spPr>
         <p:txBody>
-          <a:bodyPr wrap="square">
+          <a:bodyPr wrap="square" lIns="0" rIns="0" tIns="0" bIns="0">
             <a:spAutoFit/>
           </a:bodyPr>
           <a:lstStyle/>
@@ -5335,6 +5363,7 @@
                 <a:solidFill>
                   <a:srgbClr val="1A365D"/>
                 </a:solidFill>
+                <a:latin typeface="Calibri"/>
               </a:defRPr>
             </a:pPr>
             <a:r>
@@ -5351,8 +5380,8 @@
         </p:nvSpPr>
         <p:spPr>
           <a:xfrm>
-            <a:off x="1371600" y="502920"/>
-            <a:ext cx="9445752" cy="640080"/>
+            <a:off x="914400" y="475488"/>
+            <a:ext cx="10362895" cy="640080"/>
           </a:xfrm>
           <a:prstGeom prst="rect">
             <a:avLst/>
@@ -5360,7 +5389,7 @@
           <a:noFill/>
         </p:spPr>
         <p:txBody>
-          <a:bodyPr wrap="none">
+          <a:bodyPr wrap="none" lIns="0" rIns="0" tIns="0" bIns="0">
             <a:spAutoFit/>
           </a:bodyPr>
           <a:lstStyle/>
@@ -5370,6 +5399,7 @@
                 <a:solidFill>
                   <a:srgbClr val="1A365D"/>
                 </a:solidFill>
+                <a:latin typeface="Calibri"/>
               </a:defRPr>
             </a:pPr>
             <a:r>
@@ -5450,6 +5480,7 @@
                 <a:solidFill>
                   <a:srgbClr val="FFFFFF"/>
                 </a:solidFill>
+                <a:latin typeface="Calibri"/>
               </a:defRPr>
             </a:pPr>
             <a:r>
@@ -5466,8 +5497,8 @@
         </p:nvSpPr>
         <p:spPr>
           <a:xfrm>
-            <a:off x="640080" y="1463040"/>
-            <a:ext cx="3456432" cy="4709160"/>
+            <a:off x="731520" y="1371600"/>
+            <a:ext cx="3419856" cy="4892040"/>
           </a:xfrm>
           <a:prstGeom prst="roundRect">
             <a:avLst/>
@@ -5496,15 +5527,54 @@
           </a:fontRef>
         </p:style>
         <p:txBody>
-          <a:bodyPr rtlCol="0" anchor="ctr" wrap="square" lIns="201168" rIns="201168" tIns="502920"/>
+          <a:bodyPr rtlCol="0" anchor="ctr"/>
           <a:lstStyle/>
           <a:p>
             <a:pPr algn="ctr"/>
           </a:p>
-          <a:p>
-            <a:pPr>
-              <a:spcAft>
-                <a:spcPts val="1000"/>
+        </p:txBody>
+      </p:sp>
+      <p:sp>
+        <p:nvSpPr>
+          <p:cNvPr id="8" name="TextBox 7"/>
+          <p:cNvSpPr txBox="1"/>
+          <p:nvPr/>
+        </p:nvSpPr>
+        <p:spPr>
+          <a:xfrm>
+            <a:off x="960120" y="1572768"/>
+            <a:ext cx="2962656" cy="4489703"/>
+          </a:xfrm>
+          <a:prstGeom prst="rect">
+            <a:avLst/>
+          </a:prstGeom>
+          <a:noFill/>
+        </p:spPr>
+        <p:txBody>
+          <a:bodyPr wrap="square" lIns="0" rIns="0" tIns="0" bIns="0">
+            <a:spAutoFit/>
+          </a:bodyPr>
+          <a:lstStyle/>
+          <a:p>
+            <a:pPr>
+              <a:spcAft>
+                <a:spcPts val="1200"/>
+              </a:spcAft>
+              <a:defRPr sz="1350" b="1">
+                <a:solidFill>
+                  <a:srgbClr val="1A365D"/>
+                </a:solidFill>
+                <a:latin typeface="Calibri"/>
+              </a:defRPr>
+            </a:pPr>
+            <a:r>
+              <a:t>📊 Analysis of Feasibility</a:t>
+            </a:r>
+          </a:p>
+          <a:p>
+            <a:pPr>
+              <a:spcAft>
+                <a:spcPts val="900"/>
               </a:spcAft>
             </a:pPr>
             <a:r>
@@ -5512,6 +5582,7 @@
                 <a:solidFill>
                   <a:srgbClr val="1A365D"/>
                 </a:solidFill>
+                <a:latin typeface="Calibri"/>
               </a:rPr>
               <a:t>• Technical Feasibility:</a:t>
             </a:r>
@@ -5520,6 +5591,7 @@
                 <a:solidFill>
                   <a:srgbClr val="1E293B"/>
                 </a:solidFill>
+                <a:latin typeface="Calibri"/>
               </a:rPr>
               <a:t> Built on empirical food science principles (Fick's diffusion laws, Arrhenius kinetics) and ASTM test standards (D3985 for OTR, F1249 for WVTR). Zero speculative hardware needed.</a:t>
             </a:r>
@@ -5527,7 +5599,7 @@
           <a:p>
             <a:pPr>
               <a:spcAft>
-                <a:spcPts val="1000"/>
+                <a:spcPts val="900"/>
               </a:spcAft>
             </a:pPr>
             <a:r>
@@ -5535,6 +5607,7 @@
                 <a:solidFill>
                   <a:srgbClr val="1A365D"/>
                 </a:solidFill>
+                <a:latin typeface="Calibri"/>
               </a:rPr>
               <a:t>• Economic Viability:</a:t>
             </a:r>
@@ -5543,6 +5616,7 @@
                 <a:solidFill>
                   <a:srgbClr val="1E293B"/>
                 </a:solidFill>
+                <a:latin typeface="Calibri"/>
               </a:rPr>
               <a:t> Free open web platform for farmers and MSMEs. Delivers high ROI via 28-42% reduction in spoilage and unlocks up to ₹10 Lakhs in capital grants.</a:t>
             </a:r>
@@ -5550,7 +5624,7 @@
           <a:p>
             <a:pPr>
               <a:spcAft>
-                <a:spcPts val="1000"/>
+                <a:spcPts val="900"/>
               </a:spcAft>
             </a:pPr>
             <a:r>
@@ -5558,6 +5632,7 @@
                 <a:solidFill>
                   <a:srgbClr val="1A365D"/>
                 </a:solidFill>
+                <a:latin typeface="Calibri"/>
               </a:rPr>
               <a:t>• Operational Feasibility:</a:t>
             </a:r>
@@ -5566,62 +5641,9 @@
                 <a:solidFill>
                   <a:srgbClr val="1E293B"/>
                 </a:solidFill>
+                <a:latin typeface="Calibri"/>
               </a:rPr>
               <a:t> Dual-tier architecture: 'Simple Mode' for rural farmers/FPOs and 'Expert Mode' for packaging engineers and food technologists.</a:t>
-            </a:r>
-          </a:p>
-        </p:txBody>
-      </p:sp>
-      <p:sp>
-        <p:nvSpPr>
-          <p:cNvPr id="8" name="Rounded Rectangle 7"/>
-          <p:cNvSpPr/>
-          <p:nvPr/>
-        </p:nvSpPr>
-        <p:spPr>
-          <a:xfrm>
-            <a:off x="640080" y="1463040"/>
-            <a:ext cx="3456432" cy="384048"/>
-          </a:xfrm>
-          <a:prstGeom prst="roundRect">
-            <a:avLst/>
-          </a:prstGeom>
-          <a:solidFill>
-            <a:srgbClr val="1A365D"/>
-          </a:solidFill>
-          <a:ln>
-            <a:solidFill>
-              <a:srgbClr val="1A365D"/>
-            </a:solidFill>
-          </a:ln>
-        </p:spPr>
-        <p:style>
-          <a:lnRef idx="1">
-            <a:schemeClr val="accent1"/>
-          </a:lnRef>
-          <a:fillRef idx="3">
-            <a:schemeClr val="accent1"/>
-          </a:fillRef>
-          <a:effectRef idx="2">
-            <a:schemeClr val="accent1"/>
-          </a:effectRef>
-          <a:fontRef idx="minor">
-            <a:schemeClr val="lt1"/>
-          </a:fontRef>
-        </p:style>
-        <p:txBody>
-          <a:bodyPr rtlCol="0" anchor="ctr"/>
-          <a:lstStyle/>
-          <a:p>
-            <a:pPr algn="ctr">
-              <a:defRPr sz="1200" b="1">
-                <a:solidFill>
-                  <a:srgbClr val="FFFFFF"/>
-                </a:solidFill>
-              </a:defRPr>
-            </a:pPr>
-            <a:r>
-              <a:t>📊 Analysis of Feasibility</a:t>
             </a:r>
           </a:p>
         </p:txBody>
@@ -5634,8 +5656,8 @@
         </p:nvSpPr>
         <p:spPr>
           <a:xfrm>
-            <a:off x="4361688" y="1463040"/>
-            <a:ext cx="3456432" cy="4709160"/>
+            <a:off x="4379976" y="1371600"/>
+            <a:ext cx="3419856" cy="4892040"/>
           </a:xfrm>
           <a:prstGeom prst="roundRect">
             <a:avLst/>
@@ -5664,15 +5686,54 @@
           </a:fontRef>
         </p:style>
         <p:txBody>
-          <a:bodyPr rtlCol="0" anchor="ctr" wrap="square" lIns="201168" rIns="201168" tIns="502920"/>
+          <a:bodyPr rtlCol="0" anchor="ctr"/>
           <a:lstStyle/>
           <a:p>
             <a:pPr algn="ctr"/>
           </a:p>
-          <a:p>
-            <a:pPr>
-              <a:spcAft>
-                <a:spcPts val="1000"/>
+        </p:txBody>
+      </p:sp>
+      <p:sp>
+        <p:nvSpPr>
+          <p:cNvPr id="10" name="TextBox 9"/>
+          <p:cNvSpPr txBox="1"/>
+          <p:nvPr/>
+        </p:nvSpPr>
+        <p:spPr>
+          <a:xfrm>
+            <a:off x="4608576" y="1572768"/>
+            <a:ext cx="2962656" cy="4489703"/>
+          </a:xfrm>
+          <a:prstGeom prst="rect">
+            <a:avLst/>
+          </a:prstGeom>
+          <a:noFill/>
+        </p:spPr>
+        <p:txBody>
+          <a:bodyPr wrap="square" lIns="0" rIns="0" tIns="0" bIns="0">
+            <a:spAutoFit/>
+          </a:bodyPr>
+          <a:lstStyle/>
+          <a:p>
+            <a:pPr>
+              <a:spcAft>
+                <a:spcPts val="1200"/>
+              </a:spcAft>
+              <a:defRPr sz="1350" b="1">
+                <a:solidFill>
+                  <a:srgbClr val="D97706"/>
+                </a:solidFill>
+                <a:latin typeface="Calibri"/>
+              </a:defRPr>
+            </a:pPr>
+            <a:r>
+              <a:t>⚠️ Potential Challenges &amp; Risks</a:t>
+            </a:r>
+          </a:p>
+          <a:p>
+            <a:pPr>
+              <a:spcAft>
+                <a:spcPts val="900"/>
               </a:spcAft>
             </a:pPr>
             <a:r>
@@ -5680,6 +5741,7 @@
                 <a:solidFill>
                   <a:srgbClr val="1A365D"/>
                 </a:solidFill>
+                <a:latin typeface="Calibri"/>
               </a:rPr>
               <a:t>• Bio-Plastic Cost Premium:</a:t>
             </a:r>
@@ -5688,6 +5750,7 @@
                 <a:solidFill>
                   <a:srgbClr val="1E293B"/>
                 </a:solidFill>
+                <a:latin typeface="Calibri"/>
               </a:rPr>
               <a:t> Virgin bio-polymers (PHA/PLA) currently carry a 20-35% price premium over cheap petrochemical LDPE pouches.</a:t>
             </a:r>
@@ -5695,7 +5758,7 @@
           <a:p>
             <a:pPr>
               <a:spcAft>
-                <a:spcPts val="1000"/>
+                <a:spcPts val="900"/>
               </a:spcAft>
             </a:pPr>
             <a:r>
@@ -5703,6 +5766,7 @@
                 <a:solidFill>
                   <a:srgbClr val="1A365D"/>
                 </a:solidFill>
+                <a:latin typeface="Calibri"/>
               </a:rPr>
               <a:t>• Cold-Chain Thermal Abuse:</a:t>
             </a:r>
@@ -5711,6 +5775,7 @@
                 <a:solidFill>
                   <a:srgbClr val="1E293B"/>
                 </a:solidFill>
+                <a:latin typeface="Calibri"/>
               </a:rPr>
               <a:t> Rural transport corridors frequently experience unscheduled power outages and ambient heat spikes exceeding 38°C.</a:t>
             </a:r>
@@ -5718,7 +5783,7 @@
           <a:p>
             <a:pPr>
               <a:spcAft>
-                <a:spcPts val="1000"/>
+                <a:spcPts val="900"/>
               </a:spcAft>
             </a:pPr>
             <a:r>
@@ -5726,6 +5791,7 @@
                 <a:solidFill>
                   <a:srgbClr val="1A365D"/>
                 </a:solidFill>
+                <a:latin typeface="Calibri"/>
               </a:rPr>
               <a:t>• Agro-Produce Moisture Variance:</a:t>
             </a:r>
@@ -5734,6 +5800,7 @@
                 <a:solidFill>
                   <a:srgbClr val="1E293B"/>
                 </a:solidFill>
+                <a:latin typeface="Calibri"/>
               </a:rPr>
               <a:t> Regional and seasonal variations in fruit water activity and peel transpiration across Indian agro-climatic zones.</a:t>
             </a:r>
@@ -5741,7 +5808,7 @@
           <a:p>
             <a:pPr>
               <a:spcAft>
-                <a:spcPts val="1000"/>
+                <a:spcPts val="900"/>
               </a:spcAft>
             </a:pPr>
             <a:r>
@@ -5749,6 +5816,7 @@
                 <a:solidFill>
                   <a:srgbClr val="1A365D"/>
                 </a:solidFill>
+                <a:latin typeface="Calibri"/>
               </a:rPr>
               <a:t>• Domestic Supply Scarcity:</a:t>
             </a:r>
@@ -5757,62 +5825,9 @@
                 <a:solidFill>
                   <a:srgbClr val="1E293B"/>
                 </a:solidFill>
+                <a:latin typeface="Calibri"/>
               </a:rPr>
               <a:t> Limited conversion infrastructure in India for virgin marine-grade PHA film.</a:t>
-            </a:r>
-          </a:p>
-        </p:txBody>
-      </p:sp>
-      <p:sp>
-        <p:nvSpPr>
-          <p:cNvPr id="10" name="Rounded Rectangle 9"/>
-          <p:cNvSpPr/>
-          <p:nvPr/>
-        </p:nvSpPr>
-        <p:spPr>
-          <a:xfrm>
-            <a:off x="4361688" y="1463040"/>
-            <a:ext cx="3456432" cy="384048"/>
-          </a:xfrm>
-          <a:prstGeom prst="roundRect">
-            <a:avLst/>
-          </a:prstGeom>
-          <a:solidFill>
-            <a:srgbClr val="D97706"/>
-          </a:solidFill>
-          <a:ln>
-            <a:solidFill>
-              <a:srgbClr val="D97706"/>
-            </a:solidFill>
-          </a:ln>
-        </p:spPr>
-        <p:style>
-          <a:lnRef idx="1">
-            <a:schemeClr val="accent1"/>
-          </a:lnRef>
-          <a:fillRef idx="3">
-            <a:schemeClr val="accent1"/>
-          </a:fillRef>
-          <a:effectRef idx="2">
-            <a:schemeClr val="accent1"/>
-          </a:effectRef>
-          <a:fontRef idx="minor">
-            <a:schemeClr val="lt1"/>
-          </a:fontRef>
-        </p:style>
-        <p:txBody>
-          <a:bodyPr rtlCol="0" anchor="ctr"/>
-          <a:lstStyle/>
-          <a:p>
-            <a:pPr algn="ctr">
-              <a:defRPr sz="1200" b="1">
-                <a:solidFill>
-                  <a:srgbClr val="FFFFFF"/>
-                </a:solidFill>
-              </a:defRPr>
-            </a:pPr>
-            <a:r>
-              <a:t>⚠️ Potential Challenges &amp; Risks</a:t>
             </a:r>
           </a:p>
         </p:txBody>
@@ -5825,8 +5840,8 @@
         </p:nvSpPr>
         <p:spPr>
           <a:xfrm>
-            <a:off x="8083296" y="1463040"/>
-            <a:ext cx="3456432" cy="4709160"/>
+            <a:off x="8028432" y="1371600"/>
+            <a:ext cx="3419856" cy="4892040"/>
           </a:xfrm>
           <a:prstGeom prst="roundRect">
             <a:avLst/>
@@ -5855,15 +5870,54 @@
           </a:fontRef>
         </p:style>
         <p:txBody>
-          <a:bodyPr rtlCol="0" anchor="ctr" wrap="square" lIns="201168" rIns="201168" tIns="502920"/>
+          <a:bodyPr rtlCol="0" anchor="ctr"/>
           <a:lstStyle/>
           <a:p>
             <a:pPr algn="ctr"/>
           </a:p>
-          <a:p>
-            <a:pPr>
-              <a:spcAft>
-                <a:spcPts val="1000"/>
+        </p:txBody>
+      </p:sp>
+      <p:sp>
+        <p:nvSpPr>
+          <p:cNvPr id="12" name="TextBox 11"/>
+          <p:cNvSpPr txBox="1"/>
+          <p:nvPr/>
+        </p:nvSpPr>
+        <p:spPr>
+          <a:xfrm>
+            <a:off x="8257032" y="1572768"/>
+            <a:ext cx="2962656" cy="4489703"/>
+          </a:xfrm>
+          <a:prstGeom prst="rect">
+            <a:avLst/>
+          </a:prstGeom>
+          <a:noFill/>
+        </p:spPr>
+        <p:txBody>
+          <a:bodyPr wrap="square" lIns="0" rIns="0" tIns="0" bIns="0">
+            <a:spAutoFit/>
+          </a:bodyPr>
+          <a:lstStyle/>
+          <a:p>
+            <a:pPr>
+              <a:spcAft>
+                <a:spcPts val="1200"/>
+              </a:spcAft>
+              <a:defRPr sz="1350" b="1">
+                <a:solidFill>
+                  <a:srgbClr val="0D9488"/>
+                </a:solidFill>
+                <a:latin typeface="Calibri"/>
+              </a:defRPr>
+            </a:pPr>
+            <a:r>
+              <a:t>🛡️ Strategies for Overcoming</a:t>
+            </a:r>
+          </a:p>
+          <a:p>
+            <a:pPr>
+              <a:spcAft>
+                <a:spcPts val="900"/>
               </a:spcAft>
             </a:pPr>
             <a:r>
@@ -5871,6 +5925,7 @@
                 <a:solidFill>
                   <a:srgbClr val="1A365D"/>
                 </a:solidFill>
+                <a:latin typeface="Calibri"/>
               </a:rPr>
               <a:t>• MoFPI Capital Subsidies:</a:t>
             </a:r>
@@ -5879,6 +5934,7 @@
                 <a:solidFill>
                   <a:srgbClr val="1E293B"/>
                 </a:solidFill>
+                <a:latin typeface="Calibri"/>
               </a:rPr>
               <a:t> Offsets bio-machinery cost by directly integrating PMFME 35% capital grants (up to ₹10L) and PMKSY cluster subsidies.</a:t>
             </a:r>
@@ -5886,7 +5942,7 @@
           <a:p>
             <a:pPr>
               <a:spcAft>
-                <a:spcPts val="1000"/>
+                <a:spcPts val="900"/>
               </a:spcAft>
             </a:pPr>
             <a:r>
@@ -5894,6 +5950,7 @@
                 <a:solidFill>
                   <a:srgbClr val="1A365D"/>
                 </a:solidFill>
+                <a:latin typeface="Calibri"/>
               </a:rPr>
               <a:t>• Circular Mono-Material Fallback:</a:t>
             </a:r>
@@ -5902,6 +5959,7 @@
                 <a:solidFill>
                   <a:srgbClr val="1E293B"/>
                 </a:solidFill>
+                <a:latin typeface="Calibri"/>
               </a:rPr>
               <a:t> Recommends recyclable Mono-PP and Mono-PE barrier laminates for budget-constrained micro-enterprises alongside bio-plastics.</a:t>
             </a:r>
@@ -5909,7 +5967,7 @@
           <a:p>
             <a:pPr>
               <a:spcAft>
-                <a:spcPts val="1000"/>
+                <a:spcPts val="900"/>
               </a:spcAft>
             </a:pPr>
             <a:r>
@@ -5917,6 +5975,7 @@
                 <a:solidFill>
                   <a:srgbClr val="1A365D"/>
                 </a:solidFill>
+                <a:latin typeface="Calibri"/>
               </a:rPr>
               <a:t>• Arrhenius Thermal Shock Buffers:</a:t>
             </a:r>
@@ -5925,6 +5984,7 @@
                 <a:solidFill>
                   <a:srgbClr val="1E293B"/>
                 </a:solidFill>
+                <a:latin typeface="Calibri"/>
               </a:rPr>
               <a:t> Algorithm incorporates dynamic +10°C thermal shock safety buffers into all barrier recommendations.</a:t>
             </a:r>
@@ -5932,7 +5992,7 @@
           <a:p>
             <a:pPr>
               <a:spcAft>
-                <a:spcPts val="1000"/>
+                <a:spcPts val="900"/>
               </a:spcAft>
             </a:pPr>
             <a:r>
@@ -5940,6 +6000,7 @@
                 <a:solidFill>
                   <a:srgbClr val="1A365D"/>
                 </a:solidFill>
+                <a:latin typeface="Calibri"/>
               </a:rPr>
               <a:t>• Standardized Green Vendors:</a:t>
             </a:r>
@@ -5948,62 +6009,9 @@
                 <a:solidFill>
                   <a:srgbClr val="1E293B"/>
                 </a:solidFill>
+                <a:latin typeface="Calibri"/>
               </a:rPr>
               <a:t> Pre-calibrated material specs allow bulk aggregation and procurement from verified bio-polymer suppliers.</a:t>
-            </a:r>
-          </a:p>
-        </p:txBody>
-      </p:sp>
-      <p:sp>
-        <p:nvSpPr>
-          <p:cNvPr id="12" name="Rounded Rectangle 11"/>
-          <p:cNvSpPr/>
-          <p:nvPr/>
-        </p:nvSpPr>
-        <p:spPr>
-          <a:xfrm>
-            <a:off x="8083296" y="1463040"/>
-            <a:ext cx="3456432" cy="384048"/>
-          </a:xfrm>
-          <a:prstGeom prst="roundRect">
-            <a:avLst/>
-          </a:prstGeom>
-          <a:solidFill>
-            <a:srgbClr val="0D9488"/>
-          </a:solidFill>
-          <a:ln>
-            <a:solidFill>
-              <a:srgbClr val="0D9488"/>
-            </a:solidFill>
-          </a:ln>
-        </p:spPr>
-        <p:style>
-          <a:lnRef idx="1">
-            <a:schemeClr val="accent1"/>
-          </a:lnRef>
-          <a:fillRef idx="3">
-            <a:schemeClr val="accent1"/>
-          </a:fillRef>
-          <a:effectRef idx="2">
-            <a:schemeClr val="accent1"/>
-          </a:effectRef>
-          <a:fontRef idx="minor">
-            <a:schemeClr val="lt1"/>
-          </a:fontRef>
-        </p:style>
-        <p:txBody>
-          <a:bodyPr rtlCol="0" anchor="ctr"/>
-          <a:lstStyle/>
-          <a:p>
-            <a:pPr algn="ctr">
-              <a:defRPr sz="1200" b="1">
-                <a:solidFill>
-                  <a:srgbClr val="FFFFFF"/>
-                </a:solidFill>
-              </a:defRPr>
-            </a:pPr>
-            <a:r>
-              <a:t>🛡️ Strategies for Overcoming</a:t>
             </a:r>
           </a:p>
         </p:txBody>
@@ -6034,8 +6042,8 @@
         </p:nvSpPr>
         <p:spPr>
           <a:xfrm>
-            <a:off x="640080" y="256032"/>
-            <a:ext cx="2926080" cy="365760"/>
+            <a:off x="731520" y="256032"/>
+            <a:ext cx="3200400" cy="365760"/>
           </a:xfrm>
           <a:prstGeom prst="rect">
             <a:avLst/>
@@ -6043,7 +6051,7 @@
           <a:noFill/>
         </p:spPr>
         <p:txBody>
-          <a:bodyPr wrap="square">
+          <a:bodyPr wrap="square" lIns="0" rIns="0" tIns="0" bIns="0">
             <a:spAutoFit/>
           </a:bodyPr>
           <a:lstStyle/>
@@ -6053,6 +6061,7 @@
                 <a:solidFill>
                   <a:srgbClr val="B91C1C"/>
                 </a:solidFill>
+                <a:latin typeface="Calibri"/>
               </a:defRPr>
             </a:pPr>
             <a:r>
@@ -6069,8 +6078,8 @@
         </p:nvSpPr>
         <p:spPr>
           <a:xfrm>
-            <a:off x="8778240" y="256032"/>
-            <a:ext cx="2743200" cy="365760"/>
+            <a:off x="8229600" y="256032"/>
+            <a:ext cx="3230575" cy="365760"/>
           </a:xfrm>
           <a:prstGeom prst="rect">
             <a:avLst/>
@@ -6078,7 +6087,7 @@
           <a:noFill/>
         </p:spPr>
         <p:txBody>
-          <a:bodyPr wrap="square">
+          <a:bodyPr wrap="square" lIns="0" rIns="0" tIns="0" bIns="0">
             <a:spAutoFit/>
           </a:bodyPr>
           <a:lstStyle/>
@@ -6088,6 +6097,7 @@
                 <a:solidFill>
                   <a:srgbClr val="1A365D"/>
                 </a:solidFill>
+                <a:latin typeface="Calibri"/>
               </a:defRPr>
             </a:pPr>
             <a:r>
@@ -6104,8 +6114,8 @@
         </p:nvSpPr>
         <p:spPr>
           <a:xfrm>
-            <a:off x="1371600" y="502920"/>
-            <a:ext cx="9445752" cy="640080"/>
+            <a:off x="914400" y="475488"/>
+            <a:ext cx="10362895" cy="640080"/>
           </a:xfrm>
           <a:prstGeom prst="rect">
             <a:avLst/>
@@ -6113,7 +6123,7 @@
           <a:noFill/>
         </p:spPr>
         <p:txBody>
-          <a:bodyPr wrap="none">
+          <a:bodyPr wrap="none" lIns="0" rIns="0" tIns="0" bIns="0">
             <a:spAutoFit/>
           </a:bodyPr>
           <a:lstStyle/>
@@ -6123,6 +6133,7 @@
                 <a:solidFill>
                   <a:srgbClr val="1A365D"/>
                 </a:solidFill>
+                <a:latin typeface="Calibri"/>
               </a:defRPr>
             </a:pPr>
             <a:r>
@@ -6203,6 +6214,7 @@
                 <a:solidFill>
                   <a:srgbClr val="FFFFFF"/>
                 </a:solidFill>
+                <a:latin typeface="Calibri"/>
               </a:defRPr>
             </a:pPr>
             <a:r>
@@ -6219,8 +6231,8 @@
         </p:nvSpPr>
         <p:spPr>
           <a:xfrm>
-            <a:off x="640080" y="1371600"/>
-            <a:ext cx="3474720" cy="1051560"/>
+            <a:off x="731520" y="1353312"/>
+            <a:ext cx="3413455" cy="1051560"/>
           </a:xfrm>
           <a:prstGeom prst="roundRect">
             <a:avLst/>
@@ -6249,14 +6261,44 @@
           </a:fontRef>
         </p:style>
         <p:txBody>
-          <a:bodyPr rtlCol="0" anchor="ctr" wrap="square" lIns="182880" tIns="109728"/>
-          <a:lstStyle/>
-          <a:p>
-            <a:pPr algn="ctr">
+          <a:bodyPr rtlCol="0" anchor="ctr"/>
+          <a:lstStyle/>
+          <a:p>
+            <a:pPr algn="ctr"/>
+          </a:p>
+        </p:txBody>
+      </p:sp>
+      <p:sp>
+        <p:nvSpPr>
+          <p:cNvPr id="8" name="TextBox 7"/>
+          <p:cNvSpPr txBox="1"/>
+          <p:nvPr/>
+        </p:nvSpPr>
+        <p:spPr>
+          <a:xfrm>
+            <a:off x="960120" y="1554480"/>
+            <a:ext cx="2956255" cy="649224"/>
+          </a:xfrm>
+          <a:prstGeom prst="rect">
+            <a:avLst/>
+          </a:prstGeom>
+          <a:noFill/>
+        </p:spPr>
+        <p:txBody>
+          <a:bodyPr wrap="square" lIns="0" rIns="0" tIns="0" bIns="0">
+            <a:spAutoFit/>
+          </a:bodyPr>
+          <a:lstStyle/>
+          <a:p>
+            <a:pPr>
+              <a:spcAft>
+                <a:spcPts val="200"/>
+              </a:spcAft>
               <a:defRPr sz="1800" b="1">
                 <a:solidFill>
                   <a:srgbClr val="D97706"/>
                 </a:solidFill>
+                <a:latin typeface="Calibri"/>
               </a:defRPr>
             </a:pPr>
             <a:r>
@@ -6269,6 +6311,7 @@
                 <a:solidFill>
                   <a:srgbClr val="1E293B"/>
                 </a:solidFill>
+                <a:latin typeface="Calibri"/>
               </a:defRPr>
             </a:pPr>
             <a:r>
@@ -6283,14 +6326,14 @@
       </p:sp>
       <p:sp>
         <p:nvSpPr>
-          <p:cNvPr id="8" name="Rounded Rectangle 7"/>
+          <p:cNvPr id="9" name="Rounded Rectangle 8"/>
           <p:cNvSpPr/>
           <p:nvPr/>
         </p:nvSpPr>
         <p:spPr>
           <a:xfrm>
-            <a:off x="4343400" y="1371600"/>
-            <a:ext cx="3474720" cy="1051560"/>
+            <a:off x="4389120" y="1353312"/>
+            <a:ext cx="3413455" cy="1051560"/>
           </a:xfrm>
           <a:prstGeom prst="roundRect">
             <a:avLst/>
@@ -6319,14 +6362,44 @@
           </a:fontRef>
         </p:style>
         <p:txBody>
-          <a:bodyPr rtlCol="0" anchor="ctr" wrap="square" lIns="182880" tIns="109728"/>
-          <a:lstStyle/>
-          <a:p>
-            <a:pPr algn="ctr">
+          <a:bodyPr rtlCol="0" anchor="ctr"/>
+          <a:lstStyle/>
+          <a:p>
+            <a:pPr algn="ctr"/>
+          </a:p>
+        </p:txBody>
+      </p:sp>
+      <p:sp>
+        <p:nvSpPr>
+          <p:cNvPr id="10" name="TextBox 9"/>
+          <p:cNvSpPr txBox="1"/>
+          <p:nvPr/>
+        </p:nvSpPr>
+        <p:spPr>
+          <a:xfrm>
+            <a:off x="4617720" y="1554480"/>
+            <a:ext cx="2956255" cy="649224"/>
+          </a:xfrm>
+          <a:prstGeom prst="rect">
+            <a:avLst/>
+          </a:prstGeom>
+          <a:noFill/>
+        </p:spPr>
+        <p:txBody>
+          <a:bodyPr wrap="square" lIns="0" rIns="0" tIns="0" bIns="0">
+            <a:spAutoFit/>
+          </a:bodyPr>
+          <a:lstStyle/>
+          <a:p>
+            <a:pPr>
+              <a:spcAft>
+                <a:spcPts val="200"/>
+              </a:spcAft>
               <a:defRPr sz="1800" b="1">
                 <a:solidFill>
                   <a:srgbClr val="10B981"/>
                 </a:solidFill>
+                <a:latin typeface="Calibri"/>
               </a:defRPr>
             </a:pPr>
             <a:r>
@@ -6339,6 +6412,7 @@
                 <a:solidFill>
                   <a:srgbClr val="1E293B"/>
                 </a:solidFill>
+                <a:latin typeface="Calibri"/>
               </a:defRPr>
             </a:pPr>
             <a:r>
@@ -6353,14 +6427,14 @@
       </p:sp>
       <p:sp>
         <p:nvSpPr>
-          <p:cNvPr id="9" name="Rounded Rectangle 8"/>
+          <p:cNvPr id="11" name="Rounded Rectangle 10"/>
           <p:cNvSpPr/>
           <p:nvPr/>
         </p:nvSpPr>
         <p:spPr>
           <a:xfrm>
-            <a:off x="8046719" y="1371600"/>
-            <a:ext cx="3474720" cy="1051560"/>
+            <a:off x="8046720" y="1353312"/>
+            <a:ext cx="3413455" cy="1051560"/>
           </a:xfrm>
           <a:prstGeom prst="roundRect">
             <a:avLst/>
@@ -6389,14 +6463,44 @@
           </a:fontRef>
         </p:style>
         <p:txBody>
-          <a:bodyPr rtlCol="0" anchor="ctr" wrap="square" lIns="182880" tIns="109728"/>
-          <a:lstStyle/>
-          <a:p>
-            <a:pPr algn="ctr">
+          <a:bodyPr rtlCol="0" anchor="ctr"/>
+          <a:lstStyle/>
+          <a:p>
+            <a:pPr algn="ctr"/>
+          </a:p>
+        </p:txBody>
+      </p:sp>
+      <p:sp>
+        <p:nvSpPr>
+          <p:cNvPr id="12" name="TextBox 11"/>
+          <p:cNvSpPr txBox="1"/>
+          <p:nvPr/>
+        </p:nvSpPr>
+        <p:spPr>
+          <a:xfrm>
+            <a:off x="8275320" y="1554480"/>
+            <a:ext cx="2956255" cy="649224"/>
+          </a:xfrm>
+          <a:prstGeom prst="rect">
+            <a:avLst/>
+          </a:prstGeom>
+          <a:noFill/>
+        </p:spPr>
+        <p:txBody>
+          <a:bodyPr wrap="square" lIns="0" rIns="0" tIns="0" bIns="0">
+            <a:spAutoFit/>
+          </a:bodyPr>
+          <a:lstStyle/>
+          <a:p>
+            <a:pPr>
+              <a:spcAft>
+                <a:spcPts val="200"/>
+              </a:spcAft>
               <a:defRPr sz="1800" b="1">
                 <a:solidFill>
                   <a:srgbClr val="0284C7"/>
                 </a:solidFill>
+                <a:latin typeface="Calibri"/>
               </a:defRPr>
             </a:pPr>
             <a:r>
@@ -6409,6 +6513,7 @@
                 <a:solidFill>
                   <a:srgbClr val="1E293B"/>
                 </a:solidFill>
+                <a:latin typeface="Calibri"/>
               </a:defRPr>
             </a:pPr>
             <a:r>
@@ -6423,14 +6528,14 @@
       </p:sp>
       <p:sp>
         <p:nvSpPr>
-          <p:cNvPr id="10" name="Rounded Rectangle 9"/>
+          <p:cNvPr id="13" name="Rounded Rectangle 12"/>
           <p:cNvSpPr/>
           <p:nvPr/>
         </p:nvSpPr>
         <p:spPr>
           <a:xfrm>
-            <a:off x="640080" y="2606040"/>
-            <a:ext cx="2542032" cy="1463040"/>
+            <a:off x="731520" y="2560320"/>
+            <a:ext cx="2523744" cy="1508760"/>
           </a:xfrm>
           <a:prstGeom prst="roundRect">
             <a:avLst/>
@@ -6459,10 +6564,36 @@
           </a:fontRef>
         </p:style>
         <p:txBody>
-          <a:bodyPr rtlCol="0" anchor="ctr" wrap="square" lIns="164592" tIns="137160"/>
-          <a:lstStyle/>
-          <a:p>
-            <a:pPr algn="ctr">
+          <a:bodyPr rtlCol="0" anchor="ctr"/>
+          <a:lstStyle/>
+          <a:p>
+            <a:pPr algn="ctr"/>
+          </a:p>
+        </p:txBody>
+      </p:sp>
+      <p:sp>
+        <p:nvSpPr>
+          <p:cNvPr id="14" name="TextBox 13"/>
+          <p:cNvSpPr txBox="1"/>
+          <p:nvPr/>
+        </p:nvSpPr>
+        <p:spPr>
+          <a:xfrm>
+            <a:off x="960120" y="2761488"/>
+            <a:ext cx="2066543" cy="1106424"/>
+          </a:xfrm>
+          <a:prstGeom prst="rect">
+            <a:avLst/>
+          </a:prstGeom>
+          <a:noFill/>
+        </p:spPr>
+        <p:txBody>
+          <a:bodyPr wrap="square" lIns="0" rIns="0" tIns="0" bIns="0">
+            <a:spAutoFit/>
+          </a:bodyPr>
+          <a:lstStyle/>
+          <a:p>
+            <a:pPr>
               <a:spcAft>
                 <a:spcPts val="400"/>
               </a:spcAft>
@@ -6470,6 +6601,7 @@
                 <a:solidFill>
                   <a:srgbClr val="0284C7"/>
                 </a:solidFill>
+                <a:latin typeface="Calibri"/>
               </a:defRPr>
             </a:pPr>
             <a:r>
@@ -6482,6 +6614,7 @@
                 <a:solidFill>
                   <a:srgbClr val="1E293B"/>
                 </a:solidFill>
+                <a:latin typeface="Calibri"/>
               </a:defRPr>
             </a:pPr>
             <a:r>
@@ -6504,14 +6637,14 @@
       </p:sp>
       <p:sp>
         <p:nvSpPr>
-          <p:cNvPr id="11" name="Rounded Rectangle 10"/>
+          <p:cNvPr id="15" name="Rounded Rectangle 14"/>
           <p:cNvSpPr/>
           <p:nvPr/>
         </p:nvSpPr>
         <p:spPr>
           <a:xfrm>
-            <a:off x="3429000" y="2606040"/>
-            <a:ext cx="2542032" cy="1463040"/>
+            <a:off x="3465576" y="2560320"/>
+            <a:ext cx="2523744" cy="1508760"/>
           </a:xfrm>
           <a:prstGeom prst="roundRect">
             <a:avLst/>
@@ -6540,10 +6673,36 @@
           </a:fontRef>
         </p:style>
         <p:txBody>
-          <a:bodyPr rtlCol="0" anchor="ctr" wrap="square" lIns="164592" tIns="137160"/>
-          <a:lstStyle/>
-          <a:p>
-            <a:pPr algn="ctr">
+          <a:bodyPr rtlCol="0" anchor="ctr"/>
+          <a:lstStyle/>
+          <a:p>
+            <a:pPr algn="ctr"/>
+          </a:p>
+        </p:txBody>
+      </p:sp>
+      <p:sp>
+        <p:nvSpPr>
+          <p:cNvPr id="16" name="TextBox 15"/>
+          <p:cNvSpPr txBox="1"/>
+          <p:nvPr/>
+        </p:nvSpPr>
+        <p:spPr>
+          <a:xfrm>
+            <a:off x="3694176" y="2761488"/>
+            <a:ext cx="2066543" cy="1106424"/>
+          </a:xfrm>
+          <a:prstGeom prst="rect">
+            <a:avLst/>
+          </a:prstGeom>
+          <a:noFill/>
+        </p:spPr>
+        <p:txBody>
+          <a:bodyPr wrap="square" lIns="0" rIns="0" tIns="0" bIns="0">
+            <a:spAutoFit/>
+          </a:bodyPr>
+          <a:lstStyle/>
+          <a:p>
+            <a:pPr>
               <a:spcAft>
                 <a:spcPts val="400"/>
               </a:spcAft>
@@ -6551,6 +6710,7 @@
                 <a:solidFill>
                   <a:srgbClr val="0D9488"/>
                 </a:solidFill>
+                <a:latin typeface="Calibri"/>
               </a:defRPr>
             </a:pPr>
             <a:r>
@@ -6563,6 +6723,7 @@
                 <a:solidFill>
                   <a:srgbClr val="1E293B"/>
                 </a:solidFill>
+                <a:latin typeface="Calibri"/>
               </a:defRPr>
             </a:pPr>
             <a:r>
@@ -6585,14 +6746,14 @@
       </p:sp>
       <p:sp>
         <p:nvSpPr>
-          <p:cNvPr id="12" name="Rounded Rectangle 11"/>
+          <p:cNvPr id="17" name="Rounded Rectangle 16"/>
           <p:cNvSpPr/>
           <p:nvPr/>
         </p:nvSpPr>
         <p:spPr>
           <a:xfrm>
-            <a:off x="6217920" y="2606040"/>
-            <a:ext cx="2542032" cy="1463040"/>
+            <a:off x="6199631" y="2560320"/>
+            <a:ext cx="2523744" cy="1508760"/>
           </a:xfrm>
           <a:prstGeom prst="roundRect">
             <a:avLst/>
@@ -6621,10 +6782,36 @@
           </a:fontRef>
         </p:style>
         <p:txBody>
-          <a:bodyPr rtlCol="0" anchor="ctr" wrap="square" lIns="164592" tIns="137160"/>
-          <a:lstStyle/>
-          <a:p>
-            <a:pPr algn="ctr">
+          <a:bodyPr rtlCol="0" anchor="ctr"/>
+          <a:lstStyle/>
+          <a:p>
+            <a:pPr algn="ctr"/>
+          </a:p>
+        </p:txBody>
+      </p:sp>
+      <p:sp>
+        <p:nvSpPr>
+          <p:cNvPr id="18" name="TextBox 17"/>
+          <p:cNvSpPr txBox="1"/>
+          <p:nvPr/>
+        </p:nvSpPr>
+        <p:spPr>
+          <a:xfrm>
+            <a:off x="6428231" y="2761488"/>
+            <a:ext cx="2066543" cy="1106424"/>
+          </a:xfrm>
+          <a:prstGeom prst="rect">
+            <a:avLst/>
+          </a:prstGeom>
+          <a:noFill/>
+        </p:spPr>
+        <p:txBody>
+          <a:bodyPr wrap="square" lIns="0" rIns="0" tIns="0" bIns="0">
+            <a:spAutoFit/>
+          </a:bodyPr>
+          <a:lstStyle/>
+          <a:p>
+            <a:pPr>
               <a:spcAft>
                 <a:spcPts val="400"/>
               </a:spcAft>
@@ -6632,6 +6819,7 @@
                 <a:solidFill>
                   <a:srgbClr val="D97706"/>
                 </a:solidFill>
+                <a:latin typeface="Calibri"/>
               </a:defRPr>
             </a:pPr>
             <a:r>
@@ -6644,6 +6832,7 @@
                 <a:solidFill>
                   <a:srgbClr val="1E293B"/>
                 </a:solidFill>
+                <a:latin typeface="Calibri"/>
               </a:defRPr>
             </a:pPr>
             <a:r>
@@ -6666,14 +6855,14 @@
       </p:sp>
       <p:sp>
         <p:nvSpPr>
-          <p:cNvPr id="13" name="Rounded Rectangle 12"/>
+          <p:cNvPr id="19" name="Rounded Rectangle 18"/>
           <p:cNvSpPr/>
           <p:nvPr/>
         </p:nvSpPr>
         <p:spPr>
           <a:xfrm>
-            <a:off x="9006840" y="2606040"/>
-            <a:ext cx="2542032" cy="1463040"/>
+            <a:off x="8933688" y="2560320"/>
+            <a:ext cx="2523744" cy="1508760"/>
           </a:xfrm>
           <a:prstGeom prst="roundRect">
             <a:avLst/>
@@ -6702,10 +6891,36 @@
           </a:fontRef>
         </p:style>
         <p:txBody>
-          <a:bodyPr rtlCol="0" anchor="ctr" wrap="square" lIns="164592" tIns="137160"/>
-          <a:lstStyle/>
-          <a:p>
-            <a:pPr algn="ctr">
+          <a:bodyPr rtlCol="0" anchor="ctr"/>
+          <a:lstStyle/>
+          <a:p>
+            <a:pPr algn="ctr"/>
+          </a:p>
+        </p:txBody>
+      </p:sp>
+      <p:sp>
+        <p:nvSpPr>
+          <p:cNvPr id="20" name="TextBox 19"/>
+          <p:cNvSpPr txBox="1"/>
+          <p:nvPr/>
+        </p:nvSpPr>
+        <p:spPr>
+          <a:xfrm>
+            <a:off x="9162288" y="2761488"/>
+            <a:ext cx="2066543" cy="1106424"/>
+          </a:xfrm>
+          <a:prstGeom prst="rect">
+            <a:avLst/>
+          </a:prstGeom>
+          <a:noFill/>
+        </p:spPr>
+        <p:txBody>
+          <a:bodyPr wrap="square" lIns="0" rIns="0" tIns="0" bIns="0">
+            <a:spAutoFit/>
+          </a:bodyPr>
+          <a:lstStyle/>
+          <a:p>
+            <a:pPr>
               <a:spcAft>
                 <a:spcPts val="400"/>
               </a:spcAft>
@@ -6713,6 +6928,7 @@
                 <a:solidFill>
                   <a:srgbClr val="1A365D"/>
                 </a:solidFill>
+                <a:latin typeface="Calibri"/>
               </a:defRPr>
             </a:pPr>
             <a:r>
@@ -6725,6 +6941,7 @@
                 <a:solidFill>
                   <a:srgbClr val="1E293B"/>
                 </a:solidFill>
+                <a:latin typeface="Calibri"/>
               </a:defRPr>
             </a:pPr>
             <a:r>
@@ -6747,14 +6964,14 @@
       </p:sp>
       <p:sp>
         <p:nvSpPr>
-          <p:cNvPr id="14" name="Rounded Rectangle 13"/>
+          <p:cNvPr id="21" name="Rounded Rectangle 20"/>
           <p:cNvSpPr/>
           <p:nvPr/>
         </p:nvSpPr>
         <p:spPr>
           <a:xfrm>
-            <a:off x="640080" y="4251960"/>
-            <a:ext cx="10908792" cy="2011680"/>
+            <a:off x="731520" y="4251960"/>
+            <a:ext cx="10728655" cy="2011680"/>
           </a:xfrm>
           <a:prstGeom prst="roundRect">
             <a:avLst/>
@@ -6764,7 +6981,7 @@
           </a:solidFill>
           <a:ln w="19050">
             <a:solidFill>
-              <a:srgbClr val="E2E8F0"/>
+              <a:srgbClr val="0D9488"/>
             </a:solidFill>
           </a:ln>
         </p:spPr>
@@ -6783,10 +7000,36 @@
           </a:fontRef>
         </p:style>
         <p:txBody>
-          <a:bodyPr rtlCol="0" anchor="ctr" wrap="square" lIns="274320" tIns="182880"/>
-          <a:lstStyle/>
-          <a:p>
-            <a:pPr algn="ctr">
+          <a:bodyPr rtlCol="0" anchor="ctr"/>
+          <a:lstStyle/>
+          <a:p>
+            <a:pPr algn="ctr"/>
+          </a:p>
+        </p:txBody>
+      </p:sp>
+      <p:sp>
+        <p:nvSpPr>
+          <p:cNvPr id="22" name="TextBox 21"/>
+          <p:cNvSpPr txBox="1"/>
+          <p:nvPr/>
+        </p:nvSpPr>
+        <p:spPr>
+          <a:xfrm>
+            <a:off x="960120" y="4453128"/>
+            <a:ext cx="10271455" cy="1609344"/>
+          </a:xfrm>
+          <a:prstGeom prst="rect">
+            <a:avLst/>
+          </a:prstGeom>
+          <a:noFill/>
+        </p:spPr>
+        <p:txBody>
+          <a:bodyPr wrap="square" lIns="0" rIns="0" tIns="0" bIns="0">
+            <a:spAutoFit/>
+          </a:bodyPr>
+          <a:lstStyle/>
+          <a:p>
+            <a:pPr>
               <a:spcAft>
                 <a:spcPts val="600"/>
               </a:spcAft>
@@ -6794,6 +7037,7 @@
                 <a:solidFill>
                   <a:srgbClr val="1A365D"/>
                 </a:solidFill>
+                <a:latin typeface="Calibri"/>
               </a:defRPr>
             </a:pPr>
             <a:r>
@@ -6803,7 +7047,7 @@
           <a:p>
             <a:pPr>
               <a:spcAft>
-                <a:spcPts val="300"/>
+                <a:spcPts val="400"/>
               </a:spcAft>
             </a:pPr>
             <a:r>
@@ -6811,6 +7055,7 @@
                 <a:solidFill>
                   <a:srgbClr val="0D9488"/>
                 </a:solidFill>
+                <a:latin typeface="Calibri"/>
               </a:rPr>
               <a:t>• Up to 61% Spoilage Reduction:</a:t>
             </a:r>
@@ -6819,6 +7064,7 @@
                 <a:solidFill>
                   <a:srgbClr val="1E293B"/>
                 </a:solidFill>
+                <a:latin typeface="Calibri"/>
               </a:rPr>
               <a:t> Calibrated equilibrium modified atmosphere and moisture-wicking bio-liners prevent microbial decay.</a:t>
             </a:r>
@@ -6826,7 +7072,7 @@
           <a:p>
             <a:pPr>
               <a:spcAft>
-                <a:spcPts val="300"/>
+                <a:spcPts val="400"/>
               </a:spcAft>
             </a:pPr>
             <a:r>
@@ -6834,6 +7080,7 @@
                 <a:solidFill>
                   <a:srgbClr val="0D9488"/>
                 </a:solidFill>
+                <a:latin typeface="Calibri"/>
               </a:rPr>
               <a:t>• +150% to +450% Shelf-Life Extension:</a:t>
             </a:r>
@@ -6842,6 +7089,7 @@
                 <a:solidFill>
                   <a:srgbClr val="1E293B"/>
                 </a:solidFill>
+                <a:latin typeface="Calibri"/>
               </a:rPr>
               <a:t> Enables rural farmers and MSMEs to access distant metropolitan and lucrative export markets.</a:t>
             </a:r>
@@ -6849,7 +7097,7 @@
           <a:p>
             <a:pPr>
               <a:spcAft>
-                <a:spcPts val="300"/>
+                <a:spcPts val="400"/>
               </a:spcAft>
             </a:pPr>
             <a:r>
@@ -6857,6 +7105,7 @@
                 <a:solidFill>
                   <a:srgbClr val="0D9488"/>
                 </a:solidFill>
+                <a:latin typeface="Calibri"/>
               </a:rPr>
               <a:t>• Zero Non-Recyclable Plastic:</a:t>
             </a:r>
@@ -6865,6 +7114,7 @@
                 <a:solidFill>
                   <a:srgbClr val="1E293B"/>
                 </a:solidFill>
+                <a:latin typeface="Calibri"/>
               </a:rPr>
               <a:t> Directly replaces multi-layer metalized pouches with marine-compostable PHA and circular mono-polymers.</a:t>
             </a:r>
@@ -6872,7 +7122,7 @@
           <a:p>
             <a:pPr>
               <a:spcAft>
-                <a:spcPts val="300"/>
+                <a:spcPts val="400"/>
               </a:spcAft>
             </a:pPr>
             <a:r>
@@ -6880,6 +7130,7 @@
                 <a:solidFill>
                   <a:srgbClr val="0D9488"/>
                 </a:solidFill>
+                <a:latin typeface="Calibri"/>
               </a:rPr>
               <a:t>• Economic Empowerment:</a:t>
             </a:r>
@@ -6888,54 +7139,10 @@
                 <a:solidFill>
                   <a:srgbClr val="1E293B"/>
                 </a:solidFill>
+                <a:latin typeface="Calibri"/>
               </a:rPr>
               <a:t> Pre-filled MoFPI PMFME technical dossiers unlock up to ₹10 Lakhs in capital machinery grants for micro-units.</a:t>
             </a:r>
-          </a:p>
-        </p:txBody>
-      </p:sp>
-      <p:sp>
-        <p:nvSpPr>
-          <p:cNvPr id="15" name="Rounded Rectangle 14"/>
-          <p:cNvSpPr/>
-          <p:nvPr/>
-        </p:nvSpPr>
-        <p:spPr>
-          <a:xfrm>
-            <a:off x="640080" y="4251960"/>
-            <a:ext cx="10908792" cy="91440"/>
-          </a:xfrm>
-          <a:prstGeom prst="roundRect">
-            <a:avLst/>
-          </a:prstGeom>
-          <a:solidFill>
-            <a:srgbClr val="0D9488"/>
-          </a:solidFill>
-          <a:ln>
-            <a:solidFill>
-              <a:srgbClr val="0D9488"/>
-            </a:solidFill>
-          </a:ln>
-        </p:spPr>
-        <p:style>
-          <a:lnRef idx="1">
-            <a:schemeClr val="accent1"/>
-          </a:lnRef>
-          <a:fillRef idx="3">
-            <a:schemeClr val="accent1"/>
-          </a:fillRef>
-          <a:effectRef idx="2">
-            <a:schemeClr val="accent1"/>
-          </a:effectRef>
-          <a:fontRef idx="minor">
-            <a:schemeClr val="lt1"/>
-          </a:fontRef>
-        </p:style>
-        <p:txBody>
-          <a:bodyPr rtlCol="0" anchor="ctr"/>
-          <a:lstStyle/>
-          <a:p>
-            <a:pPr algn="ctr"/>
           </a:p>
         </p:txBody>
       </p:sp>
@@ -6965,8 +7172,8 @@
         </p:nvSpPr>
         <p:spPr>
           <a:xfrm>
-            <a:off x="640080" y="256032"/>
-            <a:ext cx="2926080" cy="365760"/>
+            <a:off x="731520" y="256032"/>
+            <a:ext cx="3200400" cy="365760"/>
           </a:xfrm>
           <a:prstGeom prst="rect">
             <a:avLst/>
@@ -6974,7 +7181,7 @@
           <a:noFill/>
         </p:spPr>
         <p:txBody>
-          <a:bodyPr wrap="square">
+          <a:bodyPr wrap="square" lIns="0" rIns="0" tIns="0" bIns="0">
             <a:spAutoFit/>
           </a:bodyPr>
           <a:lstStyle/>
@@ -6984,6 +7191,7 @@
                 <a:solidFill>
                   <a:srgbClr val="B91C1C"/>
                 </a:solidFill>
+                <a:latin typeface="Calibri"/>
               </a:defRPr>
             </a:pPr>
             <a:r>
@@ -7000,8 +7208,8 @@
         </p:nvSpPr>
         <p:spPr>
           <a:xfrm>
-            <a:off x="8778240" y="256032"/>
-            <a:ext cx="2743200" cy="365760"/>
+            <a:off x="8229600" y="256032"/>
+            <a:ext cx="3230575" cy="365760"/>
           </a:xfrm>
           <a:prstGeom prst="rect">
             <a:avLst/>
@@ -7009,7 +7217,7 @@
           <a:noFill/>
         </p:spPr>
         <p:txBody>
-          <a:bodyPr wrap="square">
+          <a:bodyPr wrap="square" lIns="0" rIns="0" tIns="0" bIns="0">
             <a:spAutoFit/>
           </a:bodyPr>
           <a:lstStyle/>
@@ -7019,6 +7227,7 @@
                 <a:solidFill>
                   <a:srgbClr val="1A365D"/>
                 </a:solidFill>
+                <a:latin typeface="Calibri"/>
               </a:defRPr>
             </a:pPr>
             <a:r>
@@ -7035,8 +7244,8 @@
         </p:nvSpPr>
         <p:spPr>
           <a:xfrm>
-            <a:off x="1371600" y="502920"/>
-            <a:ext cx="9445752" cy="640080"/>
+            <a:off x="914400" y="475488"/>
+            <a:ext cx="10362895" cy="640080"/>
           </a:xfrm>
           <a:prstGeom prst="rect">
             <a:avLst/>
@@ -7044,7 +7253,7 @@
           <a:noFill/>
         </p:spPr>
         <p:txBody>
-          <a:bodyPr wrap="none">
+          <a:bodyPr wrap="none" lIns="0" rIns="0" tIns="0" bIns="0">
             <a:spAutoFit/>
           </a:bodyPr>
           <a:lstStyle/>
@@ -7054,6 +7263,7 @@
                 <a:solidFill>
                   <a:srgbClr val="1A365D"/>
                 </a:solidFill>
+                <a:latin typeface="Calibri"/>
               </a:defRPr>
             </a:pPr>
             <a:r>
@@ -7134,6 +7344,7 @@
                 <a:solidFill>
                   <a:srgbClr val="FFFFFF"/>
                 </a:solidFill>
+                <a:latin typeface="Calibri"/>
               </a:defRPr>
             </a:pPr>
             <a:r>
@@ -7150,8 +7361,8 @@
         </p:nvSpPr>
         <p:spPr>
           <a:xfrm>
-            <a:off x="640080" y="1463040"/>
-            <a:ext cx="5257800" cy="4709160"/>
+            <a:off x="731520" y="1371600"/>
+            <a:ext cx="5166360" cy="4892040"/>
           </a:xfrm>
           <a:prstGeom prst="roundRect">
             <a:avLst/>
@@ -7180,11 +7391,50 @@
           </a:fontRef>
         </p:style>
         <p:txBody>
-          <a:bodyPr rtlCol="0" anchor="ctr" wrap="square" lIns="256032" rIns="256032" tIns="502920"/>
+          <a:bodyPr rtlCol="0" anchor="ctr"/>
           <a:lstStyle/>
           <a:p>
             <a:pPr algn="ctr"/>
           </a:p>
+        </p:txBody>
+      </p:sp>
+      <p:sp>
+        <p:nvSpPr>
+          <p:cNvPr id="8" name="TextBox 7"/>
+          <p:cNvSpPr txBox="1"/>
+          <p:nvPr/>
+        </p:nvSpPr>
+        <p:spPr>
+          <a:xfrm>
+            <a:off x="960120" y="1572768"/>
+            <a:ext cx="4709160" cy="4489703"/>
+          </a:xfrm>
+          <a:prstGeom prst="rect">
+            <a:avLst/>
+          </a:prstGeom>
+          <a:noFill/>
+        </p:spPr>
+        <p:txBody>
+          <a:bodyPr wrap="square" lIns="0" rIns="0" tIns="0" bIns="0">
+            <a:spAutoFit/>
+          </a:bodyPr>
+          <a:lstStyle/>
+          <a:p>
+            <a:pPr>
+              <a:spcAft>
+                <a:spcPts val="1200"/>
+              </a:spcAft>
+              <a:defRPr sz="1350" b="1">
+                <a:solidFill>
+                  <a:srgbClr val="1A365D"/>
+                </a:solidFill>
+                <a:latin typeface="Calibri"/>
+              </a:defRPr>
+            </a:pPr>
+            <a:r>
+              <a:t>🏛️ Government Reports &amp; Regulatory Standards</a:t>
+            </a:r>
+          </a:p>
           <a:p>
             <a:pPr>
               <a:spcAft>
@@ -7196,6 +7446,7 @@
                 <a:solidFill>
                   <a:srgbClr val="1A365D"/>
                 </a:solidFill>
+                <a:latin typeface="Calibri"/>
               </a:rPr>
               <a:t>📄 MoFPI &amp; NABCONS Study (2022):</a:t>
             </a:r>
@@ -7204,6 +7455,7 @@
                 <a:solidFill>
                   <a:srgbClr val="1E293B"/>
                 </a:solidFill>
+                <a:latin typeface="Calibri"/>
               </a:rPr>
               <a:t> 'Assessment of Post-Harvest Losses of Major Agricultural Produce and Harvest Stages in India' — Established national baseline loss metrics of 6.02-15.05% in fruits and 4.87-11.61% in vegetables.</a:t>
             </a:r>
@@ -7219,6 +7471,7 @@
                 <a:solidFill>
                   <a:srgbClr val="1A365D"/>
                 </a:solidFill>
+                <a:latin typeface="Calibri"/>
               </a:rPr>
               <a:t>📄 FSSAI Regulation (2018 / IS 9845):</a:t>
             </a:r>
@@ -7227,6 +7480,7 @@
                 <a:solidFill>
                   <a:srgbClr val="1E293B"/>
                 </a:solidFill>
+                <a:latin typeface="Calibri"/>
               </a:rPr>
               <a:t> 'Food Safety and Standards (Packaging) Regulations' — Overall migration limit &lt; 60 mg/kg (&lt; 10 mg/dm²) calibration for bio-polymer food-contact certification.</a:t>
             </a:r>
@@ -7242,6 +7496,7 @@
                 <a:solidFill>
                   <a:srgbClr val="1A365D"/>
                 </a:solidFill>
+                <a:latin typeface="Calibri"/>
               </a:rPr>
               <a:t>📄 CPCB Plastic Waste Management Rules (2026):</a:t>
             </a:r>
@@ -7250,6 +7505,7 @@
                 <a:solidFill>
                   <a:srgbClr val="1E293B"/>
                 </a:solidFill>
+                <a:latin typeface="Calibri"/>
               </a:rPr>
               <a:t> 'Guidelines on Extended Producer Responsibility (EPR) for Plastic Packaging' — Phasing out multi-layer plastics in favor of circular mono-materials and compostable bio-polymers.</a:t>
             </a:r>
@@ -7265,6 +7521,7 @@
                 <a:solidFill>
                   <a:srgbClr val="1A365D"/>
                 </a:solidFill>
+                <a:latin typeface="Calibri"/>
               </a:rPr>
               <a:t>📄 MoFPI PMFME Scheme Guidelines:</a:t>
             </a:r>
@@ -7273,62 +7530,9 @@
                 <a:solidFill>
                   <a:srgbClr val="1E293B"/>
                 </a:solidFill>
+                <a:latin typeface="Calibri"/>
               </a:rPr>
               <a:t> 'PM Formalisation of Micro food processing Enterprises Scheme' — Integration of 35% credit-linked capital grants (maximum ₹10 Lakhs) for food packaging machinery.</a:t>
-            </a:r>
-          </a:p>
-        </p:txBody>
-      </p:sp>
-      <p:sp>
-        <p:nvSpPr>
-          <p:cNvPr id="8" name="Rounded Rectangle 7"/>
-          <p:cNvSpPr/>
-          <p:nvPr/>
-        </p:nvSpPr>
-        <p:spPr>
-          <a:xfrm>
-            <a:off x="640080" y="1463040"/>
-            <a:ext cx="5257800" cy="384048"/>
-          </a:xfrm>
-          <a:prstGeom prst="roundRect">
-            <a:avLst/>
-          </a:prstGeom>
-          <a:solidFill>
-            <a:srgbClr val="1A365D"/>
-          </a:solidFill>
-          <a:ln>
-            <a:solidFill>
-              <a:srgbClr val="1A365D"/>
-            </a:solidFill>
-          </a:ln>
-        </p:spPr>
-        <p:style>
-          <a:lnRef idx="1">
-            <a:schemeClr val="accent1"/>
-          </a:lnRef>
-          <a:fillRef idx="3">
-            <a:schemeClr val="accent1"/>
-          </a:fillRef>
-          <a:effectRef idx="2">
-            <a:schemeClr val="accent1"/>
-          </a:effectRef>
-          <a:fontRef idx="minor">
-            <a:schemeClr val="lt1"/>
-          </a:fontRef>
-        </p:style>
-        <p:txBody>
-          <a:bodyPr rtlCol="0" anchor="ctr"/>
-          <a:lstStyle/>
-          <a:p>
-            <a:pPr algn="ctr">
-              <a:defRPr sz="1200" b="1">
-                <a:solidFill>
-                  <a:srgbClr val="FFFFFF"/>
-                </a:solidFill>
-              </a:defRPr>
-            </a:pPr>
-            <a:r>
-              <a:t>🏛️ Government Reports &amp; Regulatory Standards</a:t>
             </a:r>
           </a:p>
         </p:txBody>
@@ -7341,8 +7545,8 @@
         </p:nvSpPr>
         <p:spPr>
           <a:xfrm>
-            <a:off x="5167267724880" y="1463040"/>
-            <a:ext cx="5257800" cy="4709160"/>
+            <a:off x="6291072" y="1371600"/>
+            <a:ext cx="5166360" cy="4892040"/>
           </a:xfrm>
           <a:prstGeom prst="roundRect">
             <a:avLst/>
@@ -7371,11 +7575,50 @@
           </a:fontRef>
         </p:style>
         <p:txBody>
-          <a:bodyPr rtlCol="0" anchor="ctr" wrap="square" lIns="256032" rIns="256032" tIns="502920"/>
+          <a:bodyPr rtlCol="0" anchor="ctr"/>
           <a:lstStyle/>
           <a:p>
             <a:pPr algn="ctr"/>
           </a:p>
+        </p:txBody>
+      </p:sp>
+      <p:sp>
+        <p:nvSpPr>
+          <p:cNvPr id="10" name="TextBox 9"/>
+          <p:cNvSpPr txBox="1"/>
+          <p:nvPr/>
+        </p:nvSpPr>
+        <p:spPr>
+          <a:xfrm>
+            <a:off x="6519672" y="1572768"/>
+            <a:ext cx="4709160" cy="4489703"/>
+          </a:xfrm>
+          <a:prstGeom prst="rect">
+            <a:avLst/>
+          </a:prstGeom>
+          <a:noFill/>
+        </p:spPr>
+        <p:txBody>
+          <a:bodyPr wrap="square" lIns="0" rIns="0" tIns="0" bIns="0">
+            <a:spAutoFit/>
+          </a:bodyPr>
+          <a:lstStyle/>
+          <a:p>
+            <a:pPr>
+              <a:spcAft>
+                <a:spcPts val="1200"/>
+              </a:spcAft>
+              <a:defRPr sz="1350" b="1">
+                <a:solidFill>
+                  <a:srgbClr val="0D9488"/>
+                </a:solidFill>
+                <a:latin typeface="Calibri"/>
+              </a:defRPr>
+            </a:pPr>
+            <a:r>
+              <a:t>🔬 Scientific Literature &amp; ASTM Testing Protocols</a:t>
+            </a:r>
+          </a:p>
           <a:p>
             <a:pPr>
               <a:spcAft>
@@ -7387,6 +7630,7 @@
                 <a:solidFill>
                   <a:srgbClr val="0D9488"/>
                 </a:solidFill>
+                <a:latin typeface="Calibri"/>
               </a:rPr>
               <a:t>🔬 Robertson, G. L. (2016):</a:t>
             </a:r>
@@ -7395,6 +7639,7 @@
                 <a:solidFill>
                   <a:srgbClr val="1E293B"/>
                 </a:solidFill>
+                <a:latin typeface="Calibri"/>
               </a:rPr>
               <a:t> 'Food Packaging: Principles and Practice (3rd Edition)', CRC Press — Mathematical formulations for gas permeability, OTR, WVTR, and active scavenger packaging systems.</a:t>
             </a:r>
@@ -7410,6 +7655,7 @@
                 <a:solidFill>
                   <a:srgbClr val="0D9488"/>
                 </a:solidFill>
+                <a:latin typeface="Calibri"/>
               </a:rPr>
               <a:t>🔬 ASTM D3985-17 Standard:</a:t>
             </a:r>
@@ -7418,6 +7664,7 @@
                 <a:solidFill>
                   <a:srgbClr val="1E293B"/>
                 </a:solidFill>
+                <a:latin typeface="Calibri"/>
               </a:rPr>
               <a:t> 'Standard Test Method for Oxygen Gas Transmission Rate (OTR) Through Plastic Film and Sheeting Using a Coulometric Sensor' — Governs barrier categorization.</a:t>
             </a:r>
@@ -7433,6 +7680,7 @@
                 <a:solidFill>
                   <a:srgbClr val="0D9488"/>
                 </a:solidFill>
+                <a:latin typeface="Calibri"/>
               </a:rPr>
               <a:t>🔬 ASTM F1249-20 Standard:</a:t>
             </a:r>
@@ -7441,6 +7689,7 @@
                 <a:solidFill>
                   <a:srgbClr val="1E293B"/>
                 </a:solidFill>
+                <a:latin typeface="Calibri"/>
               </a:rPr>
               <a:t> 'Standard Test Method for Water Vapor Transmission Rate (WVTR) Through Plastic Film and Sheeting Using a Modulated Infrared Sensor' — Governs moisture barrier thresholds.</a:t>
             </a:r>
@@ -7456,6 +7705,7 @@
                 <a:solidFill>
                   <a:srgbClr val="0D9488"/>
                 </a:solidFill>
+                <a:latin typeface="Calibri"/>
               </a:rPr>
               <a:t>🔬 Labuza, T. P. &amp; Taoukis, P. S.:</a:t>
             </a:r>
@@ -7464,62 +7714,9 @@
                 <a:solidFill>
                   <a:srgbClr val="1E293B"/>
                 </a:solidFill>
+                <a:latin typeface="Calibri"/>
               </a:rPr>
               <a:t> 'Prediction of Food Spoilage Kinetics and Arrhenius Q10 Temperature Quotient Equations in Modified Atmosphere Packaging (MAP)' — Powers our kinetic shelf-life simulation lab.</a:t>
-            </a:r>
-          </a:p>
-        </p:txBody>
-      </p:sp>
-      <p:sp>
-        <p:nvSpPr>
-          <p:cNvPr id="10" name="Rounded Rectangle 9"/>
-          <p:cNvSpPr/>
-          <p:nvPr/>
-        </p:nvSpPr>
-        <p:spPr>
-          <a:xfrm>
-            <a:off x="5167267724880" y="1463040"/>
-            <a:ext cx="5257800" cy="384048"/>
-          </a:xfrm>
-          <a:prstGeom prst="roundRect">
-            <a:avLst/>
-          </a:prstGeom>
-          <a:solidFill>
-            <a:srgbClr val="0D9488"/>
-          </a:solidFill>
-          <a:ln>
-            <a:solidFill>
-              <a:srgbClr val="0D9488"/>
-            </a:solidFill>
-          </a:ln>
-        </p:spPr>
-        <p:style>
-          <a:lnRef idx="1">
-            <a:schemeClr val="accent1"/>
-          </a:lnRef>
-          <a:fillRef idx="3">
-            <a:schemeClr val="accent1"/>
-          </a:fillRef>
-          <a:effectRef idx="2">
-            <a:schemeClr val="accent1"/>
-          </a:effectRef>
-          <a:fontRef idx="minor">
-            <a:schemeClr val="lt1"/>
-          </a:fontRef>
-        </p:style>
-        <p:txBody>
-          <a:bodyPr rtlCol="0" anchor="ctr"/>
-          <a:lstStyle/>
-          <a:p>
-            <a:pPr algn="ctr">
-              <a:defRPr sz="1200" b="1">
-                <a:solidFill>
-                  <a:srgbClr val="FFFFFF"/>
-                </a:solidFill>
-              </a:defRPr>
-            </a:pPr>
-            <a:r>
-              <a:t>🔬 Scientific Literature &amp; ASTM Testing Protocols</a:t>
             </a:r>
           </a:p>
         </p:txBody>

</xml_diff>